<commit_message>
Filtered for and wrote out inclusion set.
</commit_message>
<xml_diff>
--- a/reports/2026-04-01_projectUpdate_2_jmoran.pptx
+++ b/reports/2026-04-01_projectUpdate_2_jmoran.pptx
@@ -5,12 +5,13 @@
     <p:sldMasterId id="2147483648" r:id="rId1"/>
   </p:sldMasterIdLst>
   <p:notesMasterIdLst>
-    <p:notesMasterId r:id="rId5"/>
+    <p:notesMasterId r:id="rId6"/>
   </p:notesMasterIdLst>
   <p:sldIdLst>
     <p:sldId id="256" r:id="rId2"/>
     <p:sldId id="266" r:id="rId3"/>
     <p:sldId id="257" r:id="rId4"/>
+    <p:sldId id="267" r:id="rId5"/>
   </p:sldIdLst>
   <p:sldSz cx="12192000" cy="6858000"/>
   <p:notesSz cx="6858000" cy="9144000"/>
@@ -5253,6 +5254,236 @@
     <p:extLst>
       <p:ext uri="{BB962C8B-B14F-4D97-AF65-F5344CB8AC3E}">
         <p14:creationId xmlns:p14="http://schemas.microsoft.com/office/powerpoint/2010/main" val="2729200426"/>
+      </p:ext>
+    </p:extLst>
+  </p:cSld>
+  <p:clrMapOvr>
+    <a:masterClrMapping/>
+  </p:clrMapOvr>
+</p:sld>
+</file>
+
+<file path=ppt/slides/slide4.xml><?xml version="1.0" encoding="utf-8"?>
+<p:sld xmlns:a="http://schemas.openxmlformats.org/drawingml/2006/main" xmlns:r="http://schemas.openxmlformats.org/officeDocument/2006/relationships" xmlns:p="http://schemas.openxmlformats.org/presentationml/2006/main">
+  <p:cSld>
+    <p:spTree>
+      <p:nvGrpSpPr>
+        <p:cNvPr id="1" name="">
+          <a:extLst>
+            <a:ext uri="{FF2B5EF4-FFF2-40B4-BE49-F238E27FC236}">
+              <a16:creationId xmlns:a16="http://schemas.microsoft.com/office/drawing/2014/main" id="{B81D5AEA-25A4-23EF-061E-6033EBF94AED}"/>
+            </a:ext>
+          </a:extLst>
+        </p:cNvPr>
+        <p:cNvGrpSpPr/>
+        <p:nvPr/>
+      </p:nvGrpSpPr>
+      <p:grpSpPr>
+        <a:xfrm>
+          <a:off x="0" y="0"/>
+          <a:ext cx="0" cy="0"/>
+          <a:chOff x="0" y="0"/>
+          <a:chExt cx="0" cy="0"/>
+        </a:xfrm>
+      </p:grpSpPr>
+      <p:sp>
+        <p:nvSpPr>
+          <p:cNvPr id="4" name="Rectangle: Rounded Corners 3">
+            <a:extLst>
+              <a:ext uri="{FF2B5EF4-FFF2-40B4-BE49-F238E27FC236}">
+                <a16:creationId xmlns:a16="http://schemas.microsoft.com/office/drawing/2014/main" id="{0C963EFC-F093-3F28-A109-DC88635409FE}"/>
+              </a:ext>
+            </a:extLst>
+          </p:cNvPr>
+          <p:cNvSpPr/>
+          <p:nvPr/>
+        </p:nvSpPr>
+        <p:spPr>
+          <a:xfrm>
+            <a:off x="315257" y="267370"/>
+            <a:ext cx="8289248" cy="628742"/>
+          </a:xfrm>
+          <a:prstGeom prst="roundRect">
+            <a:avLst/>
+          </a:prstGeom>
+          <a:solidFill>
+            <a:srgbClr val="0162B3"/>
+          </a:solidFill>
+          <a:ln>
+            <a:solidFill>
+              <a:srgbClr val="0162B3"/>
+            </a:solidFill>
+          </a:ln>
+        </p:spPr>
+        <p:style>
+          <a:lnRef idx="2">
+            <a:schemeClr val="accent1">
+              <a:shade val="50000"/>
+            </a:schemeClr>
+          </a:lnRef>
+          <a:fillRef idx="1">
+            <a:schemeClr val="accent1"/>
+          </a:fillRef>
+          <a:effectRef idx="0">
+            <a:schemeClr val="accent1"/>
+          </a:effectRef>
+          <a:fontRef idx="minor">
+            <a:schemeClr val="lt1"/>
+          </a:fontRef>
+        </p:style>
+        <p:txBody>
+          <a:bodyPr rtlCol="0" anchor="ctr"/>
+          <a:lstStyle>
+            <a:defPPr>
+              <a:defRPr lang="en-US"/>
+            </a:defPPr>
+            <a:lvl1pPr marL="0" algn="l" defTabSz="914400" rtl="0" eaLnBrk="1" latinLnBrk="0" hangingPunct="1">
+              <a:defRPr sz="1800" kern="1200">
+                <a:solidFill>
+                  <a:schemeClr val="lt1"/>
+                </a:solidFill>
+                <a:latin typeface="+mn-lt"/>
+                <a:ea typeface="+mn-ea"/>
+                <a:cs typeface="+mn-cs"/>
+              </a:defRPr>
+            </a:lvl1pPr>
+            <a:lvl2pPr marL="457200" algn="l" defTabSz="914400" rtl="0" eaLnBrk="1" latinLnBrk="0" hangingPunct="1">
+              <a:defRPr sz="1800" kern="1200">
+                <a:solidFill>
+                  <a:schemeClr val="lt1"/>
+                </a:solidFill>
+                <a:latin typeface="+mn-lt"/>
+                <a:ea typeface="+mn-ea"/>
+                <a:cs typeface="+mn-cs"/>
+              </a:defRPr>
+            </a:lvl2pPr>
+            <a:lvl3pPr marL="914400" algn="l" defTabSz="914400" rtl="0" eaLnBrk="1" latinLnBrk="0" hangingPunct="1">
+              <a:defRPr sz="1800" kern="1200">
+                <a:solidFill>
+                  <a:schemeClr val="lt1"/>
+                </a:solidFill>
+                <a:latin typeface="+mn-lt"/>
+                <a:ea typeface="+mn-ea"/>
+                <a:cs typeface="+mn-cs"/>
+              </a:defRPr>
+            </a:lvl3pPr>
+            <a:lvl4pPr marL="1371600" algn="l" defTabSz="914400" rtl="0" eaLnBrk="1" latinLnBrk="0" hangingPunct="1">
+              <a:defRPr sz="1800" kern="1200">
+                <a:solidFill>
+                  <a:schemeClr val="lt1"/>
+                </a:solidFill>
+                <a:latin typeface="+mn-lt"/>
+                <a:ea typeface="+mn-ea"/>
+                <a:cs typeface="+mn-cs"/>
+              </a:defRPr>
+            </a:lvl4pPr>
+            <a:lvl5pPr marL="1828800" algn="l" defTabSz="914400" rtl="0" eaLnBrk="1" latinLnBrk="0" hangingPunct="1">
+              <a:defRPr sz="1800" kern="1200">
+                <a:solidFill>
+                  <a:schemeClr val="lt1"/>
+                </a:solidFill>
+                <a:latin typeface="+mn-lt"/>
+                <a:ea typeface="+mn-ea"/>
+                <a:cs typeface="+mn-cs"/>
+              </a:defRPr>
+            </a:lvl5pPr>
+            <a:lvl6pPr marL="2286000" algn="l" defTabSz="914400" rtl="0" eaLnBrk="1" latinLnBrk="0" hangingPunct="1">
+              <a:defRPr sz="1800" kern="1200">
+                <a:solidFill>
+                  <a:schemeClr val="lt1"/>
+                </a:solidFill>
+                <a:latin typeface="+mn-lt"/>
+                <a:ea typeface="+mn-ea"/>
+                <a:cs typeface="+mn-cs"/>
+              </a:defRPr>
+            </a:lvl6pPr>
+            <a:lvl7pPr marL="2743200" algn="l" defTabSz="914400" rtl="0" eaLnBrk="1" latinLnBrk="0" hangingPunct="1">
+              <a:defRPr sz="1800" kern="1200">
+                <a:solidFill>
+                  <a:schemeClr val="lt1"/>
+                </a:solidFill>
+                <a:latin typeface="+mn-lt"/>
+                <a:ea typeface="+mn-ea"/>
+                <a:cs typeface="+mn-cs"/>
+              </a:defRPr>
+            </a:lvl7pPr>
+            <a:lvl8pPr marL="3200400" algn="l" defTabSz="914400" rtl="0" eaLnBrk="1" latinLnBrk="0" hangingPunct="1">
+              <a:defRPr sz="1800" kern="1200">
+                <a:solidFill>
+                  <a:schemeClr val="lt1"/>
+                </a:solidFill>
+                <a:latin typeface="+mn-lt"/>
+                <a:ea typeface="+mn-ea"/>
+                <a:cs typeface="+mn-cs"/>
+              </a:defRPr>
+            </a:lvl8pPr>
+            <a:lvl9pPr marL="3657600" algn="l" defTabSz="914400" rtl="0" eaLnBrk="1" latinLnBrk="0" hangingPunct="1">
+              <a:defRPr sz="1800" kern="1200">
+                <a:solidFill>
+                  <a:schemeClr val="lt1"/>
+                </a:solidFill>
+                <a:latin typeface="+mn-lt"/>
+                <a:ea typeface="+mn-ea"/>
+                <a:cs typeface="+mn-cs"/>
+              </a:defRPr>
+            </a:lvl9pPr>
+          </a:lstStyle>
+          <a:p>
+            <a:pPr algn="ctr"/>
+            <a:endParaRPr lang="en-CA"/>
+          </a:p>
+        </p:txBody>
+      </p:sp>
+      <p:sp>
+        <p:nvSpPr>
+          <p:cNvPr id="5" name="TextBox 4">
+            <a:extLst>
+              <a:ext uri="{FF2B5EF4-FFF2-40B4-BE49-F238E27FC236}">
+                <a16:creationId xmlns:a16="http://schemas.microsoft.com/office/drawing/2014/main" id="{64A6B9E2-84D2-B174-67D9-7AEE69C49D76}"/>
+              </a:ext>
+            </a:extLst>
+          </p:cNvPr>
+          <p:cNvSpPr txBox="1"/>
+          <p:nvPr/>
+        </p:nvSpPr>
+        <p:spPr>
+          <a:xfrm>
+            <a:off x="527960" y="335519"/>
+            <a:ext cx="7180432" cy="492443"/>
+          </a:xfrm>
+          <a:prstGeom prst="rect">
+            <a:avLst/>
+          </a:prstGeom>
+          <a:noFill/>
+        </p:spPr>
+        <p:txBody>
+          <a:bodyPr wrap="square" rtlCol="0">
+            <a:spAutoFit/>
+          </a:bodyPr>
+          <a:lstStyle/>
+          <a:p>
+            <a:r>
+              <a:rPr lang="en-US" sz="2600" b="1" dirty="0">
+                <a:solidFill>
+                  <a:schemeClr val="bg1"/>
+                </a:solidFill>
+                <a:latin typeface="Georgia Pro" panose="02040502050405020303" pitchFamily="18" charset="0"/>
+              </a:rPr>
+              <a:t>Gold standard list</a:t>
+            </a:r>
+            <a:endParaRPr lang="en-CA" sz="2600" b="1" dirty="0">
+              <a:solidFill>
+                <a:schemeClr val="bg1"/>
+              </a:solidFill>
+              <a:latin typeface="Georgia Pro" panose="02040502050405020303" pitchFamily="18" charset="0"/>
+            </a:endParaRPr>
+          </a:p>
+        </p:txBody>
+      </p:sp>
+    </p:spTree>
+    <p:extLst>
+      <p:ext uri="{BB962C8B-B14F-4D97-AF65-F5344CB8AC3E}">
+        <p14:creationId xmlns:p14="http://schemas.microsoft.com/office/powerpoint/2010/main" val="3936586944"/>
       </p:ext>
     </p:extLst>
   </p:cSld>

</xml_diff>

<commit_message>
Added gold standard list from manual curation.
</commit_message>
<xml_diff>
--- a/reports/2026-04-01_projectUpdate_2_jmoran.pptx
+++ b/reports/2026-04-01_projectUpdate_2_jmoran.pptx
@@ -491,6 +491,13 @@
           </p:nvPr>
         </p:nvSpPr>
         <p:spPr/>
+        <p:txBody>
+          <a:bodyPr/>
+          <a:lstStyle/>
+          <a:p>
+            <a:endParaRPr lang="en-CA"/>
+          </a:p>
+        </p:txBody>
       </p:sp>
       <p:sp>
         <p:nvSpPr>
@@ -5476,6 +5483,4334 @@
                 <a:schemeClr val="bg1"/>
               </a:solidFill>
               <a:latin typeface="Georgia Pro" panose="02040502050405020303" pitchFamily="18" charset="0"/>
+            </a:endParaRPr>
+          </a:p>
+        </p:txBody>
+      </p:sp>
+      <p:graphicFrame>
+        <p:nvGraphicFramePr>
+          <p:cNvPr id="2" name="Table 1">
+            <a:extLst>
+              <a:ext uri="{FF2B5EF4-FFF2-40B4-BE49-F238E27FC236}">
+                <a16:creationId xmlns:a16="http://schemas.microsoft.com/office/drawing/2014/main" id="{54FE8C64-B8A3-94B5-6509-02098D59E042}"/>
+              </a:ext>
+            </a:extLst>
+          </p:cNvPr>
+          <p:cNvGraphicFramePr>
+            <a:graphicFrameLocks noGrp="1"/>
+          </p:cNvGraphicFramePr>
+          <p:nvPr>
+            <p:extLst>
+              <p:ext uri="{D42A27DB-BD31-4B8C-83A1-F6EECF244321}">
+                <p14:modId xmlns:p14="http://schemas.microsoft.com/office/powerpoint/2010/main" val="3404926015"/>
+              </p:ext>
+            </p:extLst>
+          </p:nvPr>
+        </p:nvGraphicFramePr>
+        <p:xfrm>
+          <a:off x="1241192" y="2618867"/>
+          <a:ext cx="5347208" cy="3595370"/>
+        </p:xfrm>
+        <a:graphic>
+          <a:graphicData uri="http://schemas.openxmlformats.org/drawingml/2006/table">
+            <a:tbl>
+              <a:tblPr firstRow="1" bandRow="1">
+                <a:tableStyleId>{5940675A-B579-460E-94D1-54222C63F5DA}</a:tableStyleId>
+              </a:tblPr>
+              <a:tblGrid>
+                <a:gridCol w="930540">
+                  <a:extLst>
+                    <a:ext uri="{9D8B030D-6E8A-4147-A177-3AD203B41FA5}">
+                      <a16:colId xmlns:a16="http://schemas.microsoft.com/office/drawing/2014/main" val="529853741"/>
+                    </a:ext>
+                  </a:extLst>
+                </a:gridCol>
+                <a:gridCol w="2130668">
+                  <a:extLst>
+                    <a:ext uri="{9D8B030D-6E8A-4147-A177-3AD203B41FA5}">
+                      <a16:colId xmlns:a16="http://schemas.microsoft.com/office/drawing/2014/main" val="2430019957"/>
+                    </a:ext>
+                  </a:extLst>
+                </a:gridCol>
+                <a:gridCol w="2286000">
+                  <a:extLst>
+                    <a:ext uri="{9D8B030D-6E8A-4147-A177-3AD203B41FA5}">
+                      <a16:colId xmlns:a16="http://schemas.microsoft.com/office/drawing/2014/main" val="3749239967"/>
+                    </a:ext>
+                  </a:extLst>
+                </a:gridCol>
+              </a:tblGrid>
+              <a:tr h="140364">
+                <a:tc>
+                  <a:txBody>
+                    <a:bodyPr/>
+                    <a:lstStyle/>
+                    <a:p>
+                      <a:pPr algn="l" fontAlgn="b">
+                        <a:buNone/>
+                      </a:pPr>
+                      <a:r>
+                        <a:rPr lang="en-US" sz="1200" b="0" i="0" u="none" strike="noStrike" dirty="0">
+                          <a:solidFill>
+                            <a:srgbClr val="000000"/>
+                          </a:solidFill>
+                          <a:effectLst/>
+                          <a:latin typeface="Lucida Console" panose="020B0609040504020204" pitchFamily="49" charset="0"/>
+                        </a:rPr>
+                        <a:t>PMID</a:t>
+                      </a:r>
+                      <a:endParaRPr lang="en-CA" sz="1200" b="0" i="0" u="none" strike="noStrike" dirty="0">
+                        <a:solidFill>
+                          <a:srgbClr val="000000"/>
+                        </a:solidFill>
+                        <a:effectLst/>
+                        <a:latin typeface="Lucida Console" panose="020B0609040504020204" pitchFamily="49" charset="0"/>
+                      </a:endParaRPr>
+                    </a:p>
+                  </a:txBody>
+                  <a:tcPr marL="6350" marR="6350" marT="6350" marB="0" anchor="b">
+                    <a:lnL w="6350" cap="flat" cmpd="sng" algn="ctr">
+                      <a:solidFill>
+                        <a:schemeClr val="tx1">
+                          <a:lumMod val="95000"/>
+                          <a:lumOff val="5000"/>
+                        </a:schemeClr>
+                      </a:solidFill>
+                      <a:prstDash val="solid"/>
+                      <a:round/>
+                      <a:headEnd type="none" w="med" len="med"/>
+                      <a:tailEnd type="none" w="med" len="med"/>
+                    </a:lnL>
+                    <a:lnR w="3175" cap="flat" cmpd="sng" algn="ctr">
+                      <a:solidFill>
+                        <a:schemeClr val="tx1"/>
+                      </a:solidFill>
+                      <a:prstDash val="solid"/>
+                      <a:round/>
+                      <a:headEnd type="none" w="med" len="med"/>
+                      <a:tailEnd type="none" w="med" len="med"/>
+                    </a:lnR>
+                    <a:lnT w="6350" cap="flat" cmpd="sng" algn="ctr">
+                      <a:solidFill>
+                        <a:schemeClr val="tx1">
+                          <a:lumMod val="95000"/>
+                          <a:lumOff val="5000"/>
+                        </a:schemeClr>
+                      </a:solidFill>
+                      <a:prstDash val="solid"/>
+                      <a:round/>
+                      <a:headEnd type="none" w="med" len="med"/>
+                      <a:tailEnd type="none" w="med" len="med"/>
+                    </a:lnT>
+                    <a:lnB w="6350" cap="flat" cmpd="sng" algn="ctr">
+                      <a:solidFill>
+                        <a:schemeClr val="tx1">
+                          <a:lumMod val="95000"/>
+                          <a:lumOff val="5000"/>
+                        </a:schemeClr>
+                      </a:solidFill>
+                      <a:prstDash val="solid"/>
+                      <a:round/>
+                      <a:headEnd type="none" w="med" len="med"/>
+                      <a:tailEnd type="none" w="med" len="med"/>
+                    </a:lnB>
+                  </a:tcPr>
+                </a:tc>
+                <a:tc>
+                  <a:txBody>
+                    <a:bodyPr/>
+                    <a:lstStyle/>
+                    <a:p>
+                      <a:pPr algn="l" fontAlgn="b">
+                        <a:buNone/>
+                      </a:pPr>
+                      <a:r>
+                        <a:rPr lang="en-US" sz="1200" b="0" i="0" u="none" strike="noStrike" dirty="0">
+                          <a:solidFill>
+                            <a:srgbClr val="000000"/>
+                          </a:solidFill>
+                          <a:effectLst/>
+                          <a:latin typeface="Lucida Console" panose="020B0609040504020204" pitchFamily="49" charset="0"/>
+                        </a:rPr>
+                        <a:t>Bacterial gene name</a:t>
+                      </a:r>
+                      <a:endParaRPr lang="en-CA" sz="1200" b="0" i="0" u="none" strike="noStrike" dirty="0">
+                        <a:solidFill>
+                          <a:srgbClr val="000000"/>
+                        </a:solidFill>
+                        <a:effectLst/>
+                        <a:latin typeface="Lucida Console" panose="020B0609040504020204" pitchFamily="49" charset="0"/>
+                      </a:endParaRPr>
+                    </a:p>
+                  </a:txBody>
+                  <a:tcPr marL="6350" marR="6350" marT="6350" marB="0" anchor="b">
+                    <a:lnL w="3175" cap="flat" cmpd="sng" algn="ctr">
+                      <a:solidFill>
+                        <a:schemeClr val="tx1"/>
+                      </a:solidFill>
+                      <a:prstDash val="solid"/>
+                      <a:round/>
+                      <a:headEnd type="none" w="med" len="med"/>
+                      <a:tailEnd type="none" w="med" len="med"/>
+                    </a:lnL>
+                    <a:lnR w="3175" cap="flat" cmpd="sng" algn="ctr">
+                      <a:solidFill>
+                        <a:schemeClr val="tx1"/>
+                      </a:solidFill>
+                      <a:prstDash val="solid"/>
+                      <a:round/>
+                      <a:headEnd type="none" w="med" len="med"/>
+                      <a:tailEnd type="none" w="med" len="med"/>
+                    </a:lnR>
+                    <a:lnT w="6350" cap="flat" cmpd="sng" algn="ctr">
+                      <a:solidFill>
+                        <a:schemeClr val="tx1">
+                          <a:lumMod val="95000"/>
+                          <a:lumOff val="5000"/>
+                        </a:schemeClr>
+                      </a:solidFill>
+                      <a:prstDash val="solid"/>
+                      <a:round/>
+                      <a:headEnd type="none" w="med" len="med"/>
+                      <a:tailEnd type="none" w="med" len="med"/>
+                    </a:lnT>
+                    <a:lnB w="6350" cap="flat" cmpd="sng" algn="ctr">
+                      <a:solidFill>
+                        <a:schemeClr val="tx1">
+                          <a:lumMod val="95000"/>
+                          <a:lumOff val="5000"/>
+                        </a:schemeClr>
+                      </a:solidFill>
+                      <a:prstDash val="solid"/>
+                      <a:round/>
+                      <a:headEnd type="none" w="med" len="med"/>
+                      <a:tailEnd type="none" w="med" len="med"/>
+                    </a:lnB>
+                  </a:tcPr>
+                </a:tc>
+                <a:tc>
+                  <a:txBody>
+                    <a:bodyPr/>
+                    <a:lstStyle/>
+                    <a:p>
+                      <a:pPr algn="l" fontAlgn="b">
+                        <a:buNone/>
+                      </a:pPr>
+                      <a:r>
+                        <a:rPr lang="en-US" sz="1200" b="0" i="0" u="none" strike="noStrike" dirty="0">
+                          <a:solidFill>
+                            <a:srgbClr val="000000"/>
+                          </a:solidFill>
+                          <a:effectLst/>
+                          <a:latin typeface="Lucida Console" panose="020B0609040504020204" pitchFamily="49" charset="0"/>
+                        </a:rPr>
+                        <a:t>Human gene name</a:t>
+                      </a:r>
+                      <a:endParaRPr lang="en-CA" sz="1200" b="0" i="0" u="none" strike="noStrike" dirty="0">
+                        <a:solidFill>
+                          <a:srgbClr val="000000"/>
+                        </a:solidFill>
+                        <a:effectLst/>
+                        <a:latin typeface="Lucida Console" panose="020B0609040504020204" pitchFamily="49" charset="0"/>
+                      </a:endParaRPr>
+                    </a:p>
+                  </a:txBody>
+                  <a:tcPr marL="6350" marR="6350" marT="6350" marB="0" anchor="b">
+                    <a:lnL w="3175" cap="flat" cmpd="sng" algn="ctr">
+                      <a:solidFill>
+                        <a:schemeClr val="tx1"/>
+                      </a:solidFill>
+                      <a:prstDash val="solid"/>
+                      <a:round/>
+                      <a:headEnd type="none" w="med" len="med"/>
+                      <a:tailEnd type="none" w="med" len="med"/>
+                    </a:lnL>
+                    <a:lnR w="6350" cap="flat" cmpd="sng" algn="ctr">
+                      <a:solidFill>
+                        <a:schemeClr val="tx1">
+                          <a:lumMod val="95000"/>
+                          <a:lumOff val="5000"/>
+                        </a:schemeClr>
+                      </a:solidFill>
+                      <a:prstDash val="solid"/>
+                      <a:round/>
+                      <a:headEnd type="none" w="med" len="med"/>
+                      <a:tailEnd type="none" w="med" len="med"/>
+                    </a:lnR>
+                    <a:lnT w="6350" cap="flat" cmpd="sng" algn="ctr">
+                      <a:solidFill>
+                        <a:schemeClr val="tx1">
+                          <a:lumMod val="95000"/>
+                          <a:lumOff val="5000"/>
+                        </a:schemeClr>
+                      </a:solidFill>
+                      <a:prstDash val="solid"/>
+                      <a:round/>
+                      <a:headEnd type="none" w="med" len="med"/>
+                      <a:tailEnd type="none" w="med" len="med"/>
+                    </a:lnT>
+                    <a:lnB w="6350" cap="flat" cmpd="sng" algn="ctr">
+                      <a:solidFill>
+                        <a:schemeClr val="tx1">
+                          <a:lumMod val="95000"/>
+                          <a:lumOff val="5000"/>
+                        </a:schemeClr>
+                      </a:solidFill>
+                      <a:prstDash val="solid"/>
+                      <a:round/>
+                      <a:headEnd type="none" w="med" len="med"/>
+                      <a:tailEnd type="none" w="med" len="med"/>
+                    </a:lnB>
+                  </a:tcPr>
+                </a:tc>
+                <a:extLst>
+                  <a:ext uri="{0D108BD9-81ED-4DB2-BD59-A6C34878D82A}">
+                    <a16:rowId xmlns:a16="http://schemas.microsoft.com/office/drawing/2014/main" val="3645437008"/>
+                  </a:ext>
+                </a:extLst>
+              </a:tr>
+              <a:tr h="106163">
+                <a:tc>
+                  <a:txBody>
+                    <a:bodyPr/>
+                    <a:lstStyle/>
+                    <a:p>
+                      <a:pPr algn="ctr" fontAlgn="b">
+                        <a:buNone/>
+                      </a:pPr>
+                      <a:r>
+                        <a:rPr lang="en-CA" sz="1200" b="0" i="0" u="none" strike="noStrike" dirty="0">
+                          <a:solidFill>
+                            <a:srgbClr val="000000"/>
+                          </a:solidFill>
+                          <a:effectLst/>
+                          <a:latin typeface="Courier New" panose="02070309020205020404" pitchFamily="49" charset="0"/>
+                          <a:cs typeface="Courier New" panose="02070309020205020404" pitchFamily="49" charset="0"/>
+                        </a:rPr>
+                        <a:t>30787435</a:t>
+                      </a:r>
+                    </a:p>
+                  </a:txBody>
+                  <a:tcPr marL="6350" marR="6350" marT="6350" marB="0" anchor="b">
+                    <a:lnL w="6350" cap="flat" cmpd="sng" algn="ctr">
+                      <a:solidFill>
+                        <a:schemeClr val="tx1">
+                          <a:lumMod val="95000"/>
+                          <a:lumOff val="5000"/>
+                        </a:schemeClr>
+                      </a:solidFill>
+                      <a:prstDash val="solid"/>
+                      <a:round/>
+                      <a:headEnd type="none" w="med" len="med"/>
+                      <a:tailEnd type="none" w="med" len="med"/>
+                    </a:lnL>
+                    <a:lnR w="3175" cap="flat" cmpd="sng" algn="ctr">
+                      <a:solidFill>
+                        <a:schemeClr val="bg1">
+                          <a:lumMod val="65000"/>
+                        </a:schemeClr>
+                      </a:solidFill>
+                      <a:prstDash val="solid"/>
+                      <a:round/>
+                      <a:headEnd type="none" w="med" len="med"/>
+                      <a:tailEnd type="none" w="med" len="med"/>
+                    </a:lnR>
+                    <a:lnT w="6350" cap="flat" cmpd="sng" algn="ctr">
+                      <a:solidFill>
+                        <a:schemeClr val="tx1">
+                          <a:lumMod val="95000"/>
+                          <a:lumOff val="5000"/>
+                        </a:schemeClr>
+                      </a:solidFill>
+                      <a:prstDash val="solid"/>
+                      <a:round/>
+                      <a:headEnd type="none" w="med" len="med"/>
+                      <a:tailEnd type="none" w="med" len="med"/>
+                    </a:lnT>
+                    <a:lnB w="3175" cap="flat" cmpd="sng" algn="ctr">
+                      <a:solidFill>
+                        <a:schemeClr val="bg1">
+                          <a:lumMod val="65000"/>
+                        </a:schemeClr>
+                      </a:solidFill>
+                      <a:prstDash val="solid"/>
+                      <a:round/>
+                      <a:headEnd type="none" w="med" len="med"/>
+                      <a:tailEnd type="none" w="med" len="med"/>
+                    </a:lnB>
+                  </a:tcPr>
+                </a:tc>
+                <a:tc>
+                  <a:txBody>
+                    <a:bodyPr/>
+                    <a:lstStyle/>
+                    <a:p>
+                      <a:pPr algn="ctr" fontAlgn="b">
+                        <a:buNone/>
+                      </a:pPr>
+                      <a:r>
+                        <a:rPr lang="en-CA" sz="1200" b="0" i="0" u="none" strike="noStrike" dirty="0">
+                          <a:solidFill>
+                            <a:srgbClr val="000000"/>
+                          </a:solidFill>
+                          <a:effectLst/>
+                          <a:latin typeface="Courier New" panose="02070309020205020404" pitchFamily="49" charset="0"/>
+                          <a:cs typeface="Courier New" panose="02070309020205020404" pitchFamily="49" charset="0"/>
+                        </a:rPr>
+                        <a:t>cdnE</a:t>
+                      </a:r>
+                    </a:p>
+                  </a:txBody>
+                  <a:tcPr marL="6350" marR="6350" marT="6350" marB="0" anchor="b">
+                    <a:lnL w="3175" cap="flat" cmpd="sng" algn="ctr">
+                      <a:solidFill>
+                        <a:schemeClr val="bg1">
+                          <a:lumMod val="65000"/>
+                        </a:schemeClr>
+                      </a:solidFill>
+                      <a:prstDash val="solid"/>
+                      <a:round/>
+                      <a:headEnd type="none" w="med" len="med"/>
+                      <a:tailEnd type="none" w="med" len="med"/>
+                    </a:lnL>
+                    <a:lnR w="3175" cap="flat" cmpd="sng" algn="ctr">
+                      <a:solidFill>
+                        <a:schemeClr val="bg1">
+                          <a:lumMod val="65000"/>
+                        </a:schemeClr>
+                      </a:solidFill>
+                      <a:prstDash val="solid"/>
+                      <a:round/>
+                      <a:headEnd type="none" w="med" len="med"/>
+                      <a:tailEnd type="none" w="med" len="med"/>
+                    </a:lnR>
+                    <a:lnT w="6350" cap="flat" cmpd="sng" algn="ctr">
+                      <a:solidFill>
+                        <a:schemeClr val="tx1">
+                          <a:lumMod val="95000"/>
+                          <a:lumOff val="5000"/>
+                        </a:schemeClr>
+                      </a:solidFill>
+                      <a:prstDash val="solid"/>
+                      <a:round/>
+                      <a:headEnd type="none" w="med" len="med"/>
+                      <a:tailEnd type="none" w="med" len="med"/>
+                    </a:lnT>
+                    <a:lnB w="3175" cap="flat" cmpd="sng" algn="ctr">
+                      <a:solidFill>
+                        <a:schemeClr val="bg1">
+                          <a:lumMod val="65000"/>
+                        </a:schemeClr>
+                      </a:solidFill>
+                      <a:prstDash val="solid"/>
+                      <a:round/>
+                      <a:headEnd type="none" w="med" len="med"/>
+                      <a:tailEnd type="none" w="med" len="med"/>
+                    </a:lnB>
+                  </a:tcPr>
+                </a:tc>
+                <a:tc>
+                  <a:txBody>
+                    <a:bodyPr/>
+                    <a:lstStyle/>
+                    <a:p>
+                      <a:pPr algn="ctr" fontAlgn="b">
+                        <a:buNone/>
+                      </a:pPr>
+                      <a:r>
+                        <a:rPr lang="en-CA" sz="1200" b="0" i="0" u="none" strike="noStrike" dirty="0">
+                          <a:solidFill>
+                            <a:srgbClr val="000000"/>
+                          </a:solidFill>
+                          <a:effectLst/>
+                          <a:latin typeface="Courier New" panose="02070309020205020404" pitchFamily="49" charset="0"/>
+                          <a:cs typeface="Courier New" panose="02070309020205020404" pitchFamily="49" charset="0"/>
+                        </a:rPr>
+                        <a:t>CGAS</a:t>
+                      </a:r>
+                    </a:p>
+                  </a:txBody>
+                  <a:tcPr marL="6350" marR="6350" marT="6350" marB="0" anchor="b">
+                    <a:lnL w="3175" cap="flat" cmpd="sng" algn="ctr">
+                      <a:solidFill>
+                        <a:schemeClr val="bg1">
+                          <a:lumMod val="65000"/>
+                        </a:schemeClr>
+                      </a:solidFill>
+                      <a:prstDash val="solid"/>
+                      <a:round/>
+                      <a:headEnd type="none" w="med" len="med"/>
+                      <a:tailEnd type="none" w="med" len="med"/>
+                    </a:lnL>
+                    <a:lnR w="6350" cap="flat" cmpd="sng" algn="ctr">
+                      <a:solidFill>
+                        <a:schemeClr val="tx1">
+                          <a:lumMod val="95000"/>
+                          <a:lumOff val="5000"/>
+                        </a:schemeClr>
+                      </a:solidFill>
+                      <a:prstDash val="solid"/>
+                      <a:round/>
+                      <a:headEnd type="none" w="med" len="med"/>
+                      <a:tailEnd type="none" w="med" len="med"/>
+                    </a:lnR>
+                    <a:lnT w="6350" cap="flat" cmpd="sng" algn="ctr">
+                      <a:solidFill>
+                        <a:schemeClr val="tx1">
+                          <a:lumMod val="95000"/>
+                          <a:lumOff val="5000"/>
+                        </a:schemeClr>
+                      </a:solidFill>
+                      <a:prstDash val="solid"/>
+                      <a:round/>
+                      <a:headEnd type="none" w="med" len="med"/>
+                      <a:tailEnd type="none" w="med" len="med"/>
+                    </a:lnT>
+                    <a:lnB w="3175" cap="flat" cmpd="sng" algn="ctr">
+                      <a:solidFill>
+                        <a:schemeClr val="bg1">
+                          <a:lumMod val="65000"/>
+                        </a:schemeClr>
+                      </a:solidFill>
+                      <a:prstDash val="solid"/>
+                      <a:round/>
+                      <a:headEnd type="none" w="med" len="med"/>
+                      <a:tailEnd type="none" w="med" len="med"/>
+                    </a:lnB>
+                  </a:tcPr>
+                </a:tc>
+                <a:extLst>
+                  <a:ext uri="{0D108BD9-81ED-4DB2-BD59-A6C34878D82A}">
+                    <a16:rowId xmlns:a16="http://schemas.microsoft.com/office/drawing/2014/main" val="3588662312"/>
+                  </a:ext>
+                </a:extLst>
+              </a:tr>
+              <a:tr h="106163">
+                <a:tc>
+                  <a:txBody>
+                    <a:bodyPr/>
+                    <a:lstStyle/>
+                    <a:p>
+                      <a:pPr algn="ctr" fontAlgn="b">
+                        <a:buNone/>
+                      </a:pPr>
+                      <a:r>
+                        <a:rPr lang="en-CA" sz="1200" b="0" i="0" u="none" strike="noStrike" dirty="0">
+                          <a:solidFill>
+                            <a:srgbClr val="000000"/>
+                          </a:solidFill>
+                          <a:effectLst/>
+                          <a:latin typeface="Courier New" panose="02070309020205020404" pitchFamily="49" charset="0"/>
+                          <a:cs typeface="Courier New" panose="02070309020205020404" pitchFamily="49" charset="0"/>
+                        </a:rPr>
+                        <a:t>30787435</a:t>
+                      </a:r>
+                    </a:p>
+                  </a:txBody>
+                  <a:tcPr marL="6350" marR="6350" marT="6350" marB="0" anchor="b">
+                    <a:lnL w="6350" cap="flat" cmpd="sng" algn="ctr">
+                      <a:solidFill>
+                        <a:schemeClr val="tx1">
+                          <a:lumMod val="95000"/>
+                          <a:lumOff val="5000"/>
+                        </a:schemeClr>
+                      </a:solidFill>
+                      <a:prstDash val="solid"/>
+                      <a:round/>
+                      <a:headEnd type="none" w="med" len="med"/>
+                      <a:tailEnd type="none" w="med" len="med"/>
+                    </a:lnL>
+                    <a:lnR w="3175" cap="flat" cmpd="sng" algn="ctr">
+                      <a:solidFill>
+                        <a:schemeClr val="bg1">
+                          <a:lumMod val="65000"/>
+                        </a:schemeClr>
+                      </a:solidFill>
+                      <a:prstDash val="solid"/>
+                      <a:round/>
+                      <a:headEnd type="none" w="med" len="med"/>
+                      <a:tailEnd type="none" w="med" len="med"/>
+                    </a:lnR>
+                    <a:lnT w="3175" cap="flat" cmpd="sng" algn="ctr">
+                      <a:solidFill>
+                        <a:schemeClr val="bg1">
+                          <a:lumMod val="65000"/>
+                        </a:schemeClr>
+                      </a:solidFill>
+                      <a:prstDash val="solid"/>
+                      <a:round/>
+                      <a:headEnd type="none" w="med" len="med"/>
+                      <a:tailEnd type="none" w="med" len="med"/>
+                    </a:lnT>
+                    <a:lnB w="3175" cap="flat" cmpd="sng" algn="ctr">
+                      <a:solidFill>
+                        <a:schemeClr val="bg1">
+                          <a:lumMod val="65000"/>
+                        </a:schemeClr>
+                      </a:solidFill>
+                      <a:prstDash val="solid"/>
+                      <a:round/>
+                      <a:headEnd type="none" w="med" len="med"/>
+                      <a:tailEnd type="none" w="med" len="med"/>
+                    </a:lnB>
+                  </a:tcPr>
+                </a:tc>
+                <a:tc>
+                  <a:txBody>
+                    <a:bodyPr/>
+                    <a:lstStyle/>
+                    <a:p>
+                      <a:pPr algn="ctr" fontAlgn="b">
+                        <a:buNone/>
+                      </a:pPr>
+                      <a:r>
+                        <a:rPr lang="en-CA" sz="1200" b="0" i="0" u="none" strike="noStrike" dirty="0">
+                          <a:solidFill>
+                            <a:srgbClr val="000000"/>
+                          </a:solidFill>
+                          <a:effectLst/>
+                          <a:latin typeface="Courier New" panose="02070309020205020404" pitchFamily="49" charset="0"/>
+                          <a:cs typeface="Courier New" panose="02070309020205020404" pitchFamily="49" charset="0"/>
+                        </a:rPr>
+                        <a:t>cdnE</a:t>
+                      </a:r>
+                    </a:p>
+                  </a:txBody>
+                  <a:tcPr marL="6350" marR="6350" marT="6350" marB="0" anchor="b">
+                    <a:lnL w="3175" cap="flat" cmpd="sng" algn="ctr">
+                      <a:solidFill>
+                        <a:schemeClr val="bg1">
+                          <a:lumMod val="65000"/>
+                        </a:schemeClr>
+                      </a:solidFill>
+                      <a:prstDash val="solid"/>
+                      <a:round/>
+                      <a:headEnd type="none" w="med" len="med"/>
+                      <a:tailEnd type="none" w="med" len="med"/>
+                    </a:lnL>
+                    <a:lnR w="3175" cap="flat" cmpd="sng" algn="ctr">
+                      <a:solidFill>
+                        <a:schemeClr val="bg1">
+                          <a:lumMod val="65000"/>
+                        </a:schemeClr>
+                      </a:solidFill>
+                      <a:prstDash val="solid"/>
+                      <a:round/>
+                      <a:headEnd type="none" w="med" len="med"/>
+                      <a:tailEnd type="none" w="med" len="med"/>
+                    </a:lnR>
+                    <a:lnT w="3175" cap="flat" cmpd="sng" algn="ctr">
+                      <a:solidFill>
+                        <a:schemeClr val="bg1">
+                          <a:lumMod val="65000"/>
+                        </a:schemeClr>
+                      </a:solidFill>
+                      <a:prstDash val="solid"/>
+                      <a:round/>
+                      <a:headEnd type="none" w="med" len="med"/>
+                      <a:tailEnd type="none" w="med" len="med"/>
+                    </a:lnT>
+                    <a:lnB w="3175" cap="flat" cmpd="sng" algn="ctr">
+                      <a:solidFill>
+                        <a:schemeClr val="bg1">
+                          <a:lumMod val="65000"/>
+                        </a:schemeClr>
+                      </a:solidFill>
+                      <a:prstDash val="solid"/>
+                      <a:round/>
+                      <a:headEnd type="none" w="med" len="med"/>
+                      <a:tailEnd type="none" w="med" len="med"/>
+                    </a:lnB>
+                  </a:tcPr>
+                </a:tc>
+                <a:tc>
+                  <a:txBody>
+                    <a:bodyPr/>
+                    <a:lstStyle/>
+                    <a:p>
+                      <a:pPr algn="ctr" fontAlgn="b">
+                        <a:buNone/>
+                      </a:pPr>
+                      <a:r>
+                        <a:rPr lang="en-CA" sz="1200" b="0" i="0" u="none" strike="noStrike">
+                          <a:solidFill>
+                            <a:srgbClr val="000000"/>
+                          </a:solidFill>
+                          <a:effectLst/>
+                          <a:latin typeface="Courier New" panose="02070309020205020404" pitchFamily="49" charset="0"/>
+                          <a:cs typeface="Courier New" panose="02070309020205020404" pitchFamily="49" charset="0"/>
+                        </a:rPr>
+                        <a:t>CGAS</a:t>
+                      </a:r>
+                    </a:p>
+                  </a:txBody>
+                  <a:tcPr marL="6350" marR="6350" marT="6350" marB="0" anchor="b">
+                    <a:lnL w="3175" cap="flat" cmpd="sng" algn="ctr">
+                      <a:solidFill>
+                        <a:schemeClr val="bg1">
+                          <a:lumMod val="65000"/>
+                        </a:schemeClr>
+                      </a:solidFill>
+                      <a:prstDash val="solid"/>
+                      <a:round/>
+                      <a:headEnd type="none" w="med" len="med"/>
+                      <a:tailEnd type="none" w="med" len="med"/>
+                    </a:lnL>
+                    <a:lnR w="6350" cap="flat" cmpd="sng" algn="ctr">
+                      <a:solidFill>
+                        <a:schemeClr val="tx1">
+                          <a:lumMod val="95000"/>
+                          <a:lumOff val="5000"/>
+                        </a:schemeClr>
+                      </a:solidFill>
+                      <a:prstDash val="solid"/>
+                      <a:round/>
+                      <a:headEnd type="none" w="med" len="med"/>
+                      <a:tailEnd type="none" w="med" len="med"/>
+                    </a:lnR>
+                    <a:lnT w="3175" cap="flat" cmpd="sng" algn="ctr">
+                      <a:solidFill>
+                        <a:schemeClr val="bg1">
+                          <a:lumMod val="65000"/>
+                        </a:schemeClr>
+                      </a:solidFill>
+                      <a:prstDash val="solid"/>
+                      <a:round/>
+                      <a:headEnd type="none" w="med" len="med"/>
+                      <a:tailEnd type="none" w="med" len="med"/>
+                    </a:lnT>
+                    <a:lnB w="3175" cap="flat" cmpd="sng" algn="ctr">
+                      <a:solidFill>
+                        <a:schemeClr val="bg1">
+                          <a:lumMod val="65000"/>
+                        </a:schemeClr>
+                      </a:solidFill>
+                      <a:prstDash val="solid"/>
+                      <a:round/>
+                      <a:headEnd type="none" w="med" len="med"/>
+                      <a:tailEnd type="none" w="med" len="med"/>
+                    </a:lnB>
+                  </a:tcPr>
+                </a:tc>
+                <a:extLst>
+                  <a:ext uri="{0D108BD9-81ED-4DB2-BD59-A6C34878D82A}">
+                    <a16:rowId xmlns:a16="http://schemas.microsoft.com/office/drawing/2014/main" val="3506748293"/>
+                  </a:ext>
+                </a:extLst>
+              </a:tr>
+              <a:tr h="106163">
+                <a:tc>
+                  <a:txBody>
+                    <a:bodyPr/>
+                    <a:lstStyle/>
+                    <a:p>
+                      <a:pPr algn="ctr" fontAlgn="b">
+                        <a:buNone/>
+                      </a:pPr>
+                      <a:r>
+                        <a:rPr lang="en-CA" sz="1200" b="0" i="0" u="none" strike="noStrike" dirty="0">
+                          <a:solidFill>
+                            <a:srgbClr val="000000"/>
+                          </a:solidFill>
+                          <a:effectLst/>
+                          <a:latin typeface="Courier New" panose="02070309020205020404" pitchFamily="49" charset="0"/>
+                          <a:cs typeface="Courier New" panose="02070309020205020404" pitchFamily="49" charset="0"/>
+                        </a:rPr>
+                        <a:t>40705877</a:t>
+                      </a:r>
+                    </a:p>
+                  </a:txBody>
+                  <a:tcPr marL="6350" marR="6350" marT="6350" marB="0" anchor="b">
+                    <a:lnL w="6350" cap="flat" cmpd="sng" algn="ctr">
+                      <a:solidFill>
+                        <a:schemeClr val="tx1">
+                          <a:lumMod val="95000"/>
+                          <a:lumOff val="5000"/>
+                        </a:schemeClr>
+                      </a:solidFill>
+                      <a:prstDash val="solid"/>
+                      <a:round/>
+                      <a:headEnd type="none" w="med" len="med"/>
+                      <a:tailEnd type="none" w="med" len="med"/>
+                    </a:lnL>
+                    <a:lnR w="3175" cap="flat" cmpd="sng" algn="ctr">
+                      <a:solidFill>
+                        <a:schemeClr val="bg1">
+                          <a:lumMod val="65000"/>
+                        </a:schemeClr>
+                      </a:solidFill>
+                      <a:prstDash val="solid"/>
+                      <a:round/>
+                      <a:headEnd type="none" w="med" len="med"/>
+                      <a:tailEnd type="none" w="med" len="med"/>
+                    </a:lnR>
+                    <a:lnT w="3175" cap="flat" cmpd="sng" algn="ctr">
+                      <a:solidFill>
+                        <a:schemeClr val="bg1">
+                          <a:lumMod val="65000"/>
+                        </a:schemeClr>
+                      </a:solidFill>
+                      <a:prstDash val="solid"/>
+                      <a:round/>
+                      <a:headEnd type="none" w="med" len="med"/>
+                      <a:tailEnd type="none" w="med" len="med"/>
+                    </a:lnT>
+                    <a:lnB w="3175" cap="flat" cmpd="sng" algn="ctr">
+                      <a:solidFill>
+                        <a:schemeClr val="bg1">
+                          <a:lumMod val="65000"/>
+                        </a:schemeClr>
+                      </a:solidFill>
+                      <a:prstDash val="solid"/>
+                      <a:round/>
+                      <a:headEnd type="none" w="med" len="med"/>
+                      <a:tailEnd type="none" w="med" len="med"/>
+                    </a:lnB>
+                  </a:tcPr>
+                </a:tc>
+                <a:tc>
+                  <a:txBody>
+                    <a:bodyPr/>
+                    <a:lstStyle/>
+                    <a:p>
+                      <a:pPr algn="ctr" fontAlgn="b">
+                        <a:buNone/>
+                      </a:pPr>
+                      <a:r>
+                        <a:rPr lang="en-CA" sz="1200" b="0" i="0" u="none" strike="noStrike" dirty="0">
+                          <a:solidFill>
+                            <a:srgbClr val="000000"/>
+                          </a:solidFill>
+                          <a:effectLst/>
+                          <a:latin typeface="Courier New" panose="02070309020205020404" pitchFamily="49" charset="0"/>
+                          <a:cs typeface="Courier New" panose="02070309020205020404" pitchFamily="49" charset="0"/>
+                        </a:rPr>
+                        <a:t>ThsA</a:t>
+                      </a:r>
+                    </a:p>
+                  </a:txBody>
+                  <a:tcPr marL="6350" marR="6350" marT="6350" marB="0" anchor="b">
+                    <a:lnL w="3175" cap="flat" cmpd="sng" algn="ctr">
+                      <a:solidFill>
+                        <a:schemeClr val="bg1">
+                          <a:lumMod val="65000"/>
+                        </a:schemeClr>
+                      </a:solidFill>
+                      <a:prstDash val="solid"/>
+                      <a:round/>
+                      <a:headEnd type="none" w="med" len="med"/>
+                      <a:tailEnd type="none" w="med" len="med"/>
+                    </a:lnL>
+                    <a:lnR w="3175" cap="flat" cmpd="sng" algn="ctr">
+                      <a:solidFill>
+                        <a:schemeClr val="bg1">
+                          <a:lumMod val="65000"/>
+                        </a:schemeClr>
+                      </a:solidFill>
+                      <a:prstDash val="solid"/>
+                      <a:round/>
+                      <a:headEnd type="none" w="med" len="med"/>
+                      <a:tailEnd type="none" w="med" len="med"/>
+                    </a:lnR>
+                    <a:lnT w="3175" cap="flat" cmpd="sng" algn="ctr">
+                      <a:solidFill>
+                        <a:schemeClr val="bg1">
+                          <a:lumMod val="65000"/>
+                        </a:schemeClr>
+                      </a:solidFill>
+                      <a:prstDash val="solid"/>
+                      <a:round/>
+                      <a:headEnd type="none" w="med" len="med"/>
+                      <a:tailEnd type="none" w="med" len="med"/>
+                    </a:lnT>
+                    <a:lnB w="3175" cap="flat" cmpd="sng" algn="ctr">
+                      <a:solidFill>
+                        <a:schemeClr val="bg1">
+                          <a:lumMod val="65000"/>
+                        </a:schemeClr>
+                      </a:solidFill>
+                      <a:prstDash val="solid"/>
+                      <a:round/>
+                      <a:headEnd type="none" w="med" len="med"/>
+                      <a:tailEnd type="none" w="med" len="med"/>
+                    </a:lnB>
+                  </a:tcPr>
+                </a:tc>
+                <a:tc>
+                  <a:txBody>
+                    <a:bodyPr/>
+                    <a:lstStyle/>
+                    <a:p>
+                      <a:pPr algn="ctr" fontAlgn="b">
+                        <a:buNone/>
+                      </a:pPr>
+                      <a:r>
+                        <a:rPr lang="en-CA" sz="1200" b="0" i="0" u="none" strike="noStrike">
+                          <a:solidFill>
+                            <a:srgbClr val="000000"/>
+                          </a:solidFill>
+                          <a:effectLst/>
+                          <a:latin typeface="Courier New" panose="02070309020205020404" pitchFamily="49" charset="0"/>
+                          <a:cs typeface="Courier New" panose="02070309020205020404" pitchFamily="49" charset="0"/>
+                        </a:rPr>
+                        <a:t>FAM118B</a:t>
+                      </a:r>
+                    </a:p>
+                  </a:txBody>
+                  <a:tcPr marL="6350" marR="6350" marT="6350" marB="0" anchor="b">
+                    <a:lnL w="3175" cap="flat" cmpd="sng" algn="ctr">
+                      <a:solidFill>
+                        <a:schemeClr val="bg1">
+                          <a:lumMod val="65000"/>
+                        </a:schemeClr>
+                      </a:solidFill>
+                      <a:prstDash val="solid"/>
+                      <a:round/>
+                      <a:headEnd type="none" w="med" len="med"/>
+                      <a:tailEnd type="none" w="med" len="med"/>
+                    </a:lnL>
+                    <a:lnR w="6350" cap="flat" cmpd="sng" algn="ctr">
+                      <a:solidFill>
+                        <a:schemeClr val="tx1">
+                          <a:lumMod val="95000"/>
+                          <a:lumOff val="5000"/>
+                        </a:schemeClr>
+                      </a:solidFill>
+                      <a:prstDash val="solid"/>
+                      <a:round/>
+                      <a:headEnd type="none" w="med" len="med"/>
+                      <a:tailEnd type="none" w="med" len="med"/>
+                    </a:lnR>
+                    <a:lnT w="3175" cap="flat" cmpd="sng" algn="ctr">
+                      <a:solidFill>
+                        <a:schemeClr val="bg1">
+                          <a:lumMod val="65000"/>
+                        </a:schemeClr>
+                      </a:solidFill>
+                      <a:prstDash val="solid"/>
+                      <a:round/>
+                      <a:headEnd type="none" w="med" len="med"/>
+                      <a:tailEnd type="none" w="med" len="med"/>
+                    </a:lnT>
+                    <a:lnB w="3175" cap="flat" cmpd="sng" algn="ctr">
+                      <a:solidFill>
+                        <a:schemeClr val="bg1">
+                          <a:lumMod val="65000"/>
+                        </a:schemeClr>
+                      </a:solidFill>
+                      <a:prstDash val="solid"/>
+                      <a:round/>
+                      <a:headEnd type="none" w="med" len="med"/>
+                      <a:tailEnd type="none" w="med" len="med"/>
+                    </a:lnB>
+                  </a:tcPr>
+                </a:tc>
+                <a:extLst>
+                  <a:ext uri="{0D108BD9-81ED-4DB2-BD59-A6C34878D82A}">
+                    <a16:rowId xmlns:a16="http://schemas.microsoft.com/office/drawing/2014/main" val="84402613"/>
+                  </a:ext>
+                </a:extLst>
+              </a:tr>
+              <a:tr h="106163">
+                <a:tc>
+                  <a:txBody>
+                    <a:bodyPr/>
+                    <a:lstStyle/>
+                    <a:p>
+                      <a:pPr algn="ctr" fontAlgn="b">
+                        <a:buNone/>
+                      </a:pPr>
+                      <a:r>
+                        <a:rPr lang="en-CA" sz="1200" b="0" i="0" u="none" strike="noStrike">
+                          <a:solidFill>
+                            <a:srgbClr val="000000"/>
+                          </a:solidFill>
+                          <a:effectLst/>
+                          <a:latin typeface="Courier New" panose="02070309020205020404" pitchFamily="49" charset="0"/>
+                          <a:cs typeface="Courier New" panose="02070309020205020404" pitchFamily="49" charset="0"/>
+                        </a:rPr>
+                        <a:t>40705877</a:t>
+                      </a:r>
+                    </a:p>
+                  </a:txBody>
+                  <a:tcPr marL="6350" marR="6350" marT="6350" marB="0" anchor="b">
+                    <a:lnL w="6350" cap="flat" cmpd="sng" algn="ctr">
+                      <a:solidFill>
+                        <a:schemeClr val="tx1">
+                          <a:lumMod val="95000"/>
+                          <a:lumOff val="5000"/>
+                        </a:schemeClr>
+                      </a:solidFill>
+                      <a:prstDash val="solid"/>
+                      <a:round/>
+                      <a:headEnd type="none" w="med" len="med"/>
+                      <a:tailEnd type="none" w="med" len="med"/>
+                    </a:lnL>
+                    <a:lnR w="3175" cap="flat" cmpd="sng" algn="ctr">
+                      <a:solidFill>
+                        <a:schemeClr val="bg1">
+                          <a:lumMod val="65000"/>
+                        </a:schemeClr>
+                      </a:solidFill>
+                      <a:prstDash val="solid"/>
+                      <a:round/>
+                      <a:headEnd type="none" w="med" len="med"/>
+                      <a:tailEnd type="none" w="med" len="med"/>
+                    </a:lnR>
+                    <a:lnT w="3175" cap="flat" cmpd="sng" algn="ctr">
+                      <a:solidFill>
+                        <a:schemeClr val="bg1">
+                          <a:lumMod val="65000"/>
+                        </a:schemeClr>
+                      </a:solidFill>
+                      <a:prstDash val="solid"/>
+                      <a:round/>
+                      <a:headEnd type="none" w="med" len="med"/>
+                      <a:tailEnd type="none" w="med" len="med"/>
+                    </a:lnT>
+                    <a:lnB w="3175" cap="flat" cmpd="sng" algn="ctr">
+                      <a:solidFill>
+                        <a:schemeClr val="bg1">
+                          <a:lumMod val="65000"/>
+                        </a:schemeClr>
+                      </a:solidFill>
+                      <a:prstDash val="solid"/>
+                      <a:round/>
+                      <a:headEnd type="none" w="med" len="med"/>
+                      <a:tailEnd type="none" w="med" len="med"/>
+                    </a:lnB>
+                  </a:tcPr>
+                </a:tc>
+                <a:tc>
+                  <a:txBody>
+                    <a:bodyPr/>
+                    <a:lstStyle/>
+                    <a:p>
+                      <a:pPr algn="ctr" fontAlgn="b">
+                        <a:buNone/>
+                      </a:pPr>
+                      <a:r>
+                        <a:rPr lang="en-CA" sz="1200" b="0" i="0" u="none" strike="noStrike" dirty="0">
+                          <a:solidFill>
+                            <a:srgbClr val="000000"/>
+                          </a:solidFill>
+                          <a:effectLst/>
+                          <a:latin typeface="Courier New" panose="02070309020205020404" pitchFamily="49" charset="0"/>
+                          <a:cs typeface="Courier New" panose="02070309020205020404" pitchFamily="49" charset="0"/>
+                        </a:rPr>
+                        <a:t>ThsA</a:t>
+                      </a:r>
+                    </a:p>
+                  </a:txBody>
+                  <a:tcPr marL="6350" marR="6350" marT="6350" marB="0" anchor="b">
+                    <a:lnL w="3175" cap="flat" cmpd="sng" algn="ctr">
+                      <a:solidFill>
+                        <a:schemeClr val="bg1">
+                          <a:lumMod val="65000"/>
+                        </a:schemeClr>
+                      </a:solidFill>
+                      <a:prstDash val="solid"/>
+                      <a:round/>
+                      <a:headEnd type="none" w="med" len="med"/>
+                      <a:tailEnd type="none" w="med" len="med"/>
+                    </a:lnL>
+                    <a:lnR w="3175" cap="flat" cmpd="sng" algn="ctr">
+                      <a:solidFill>
+                        <a:schemeClr val="bg1">
+                          <a:lumMod val="65000"/>
+                        </a:schemeClr>
+                      </a:solidFill>
+                      <a:prstDash val="solid"/>
+                      <a:round/>
+                      <a:headEnd type="none" w="med" len="med"/>
+                      <a:tailEnd type="none" w="med" len="med"/>
+                    </a:lnR>
+                    <a:lnT w="3175" cap="flat" cmpd="sng" algn="ctr">
+                      <a:solidFill>
+                        <a:schemeClr val="bg1">
+                          <a:lumMod val="65000"/>
+                        </a:schemeClr>
+                      </a:solidFill>
+                      <a:prstDash val="solid"/>
+                      <a:round/>
+                      <a:headEnd type="none" w="med" len="med"/>
+                      <a:tailEnd type="none" w="med" len="med"/>
+                    </a:lnT>
+                    <a:lnB w="3175" cap="flat" cmpd="sng" algn="ctr">
+                      <a:solidFill>
+                        <a:schemeClr val="bg1">
+                          <a:lumMod val="65000"/>
+                        </a:schemeClr>
+                      </a:solidFill>
+                      <a:prstDash val="solid"/>
+                      <a:round/>
+                      <a:headEnd type="none" w="med" len="med"/>
+                      <a:tailEnd type="none" w="med" len="med"/>
+                    </a:lnB>
+                  </a:tcPr>
+                </a:tc>
+                <a:tc>
+                  <a:txBody>
+                    <a:bodyPr/>
+                    <a:lstStyle/>
+                    <a:p>
+                      <a:pPr algn="ctr" fontAlgn="b">
+                        <a:buNone/>
+                      </a:pPr>
+                      <a:r>
+                        <a:rPr lang="en-CA" sz="1200" b="0" i="0" u="none" strike="noStrike">
+                          <a:solidFill>
+                            <a:srgbClr val="000000"/>
+                          </a:solidFill>
+                          <a:effectLst/>
+                          <a:latin typeface="Courier New" panose="02070309020205020404" pitchFamily="49" charset="0"/>
+                          <a:cs typeface="Courier New" panose="02070309020205020404" pitchFamily="49" charset="0"/>
+                        </a:rPr>
+                        <a:t>SIRT1</a:t>
+                      </a:r>
+                    </a:p>
+                  </a:txBody>
+                  <a:tcPr marL="6350" marR="6350" marT="6350" marB="0" anchor="b">
+                    <a:lnL w="3175" cap="flat" cmpd="sng" algn="ctr">
+                      <a:solidFill>
+                        <a:schemeClr val="bg1">
+                          <a:lumMod val="65000"/>
+                        </a:schemeClr>
+                      </a:solidFill>
+                      <a:prstDash val="solid"/>
+                      <a:round/>
+                      <a:headEnd type="none" w="med" len="med"/>
+                      <a:tailEnd type="none" w="med" len="med"/>
+                    </a:lnL>
+                    <a:lnR w="6350" cap="flat" cmpd="sng" algn="ctr">
+                      <a:solidFill>
+                        <a:schemeClr val="tx1">
+                          <a:lumMod val="95000"/>
+                          <a:lumOff val="5000"/>
+                        </a:schemeClr>
+                      </a:solidFill>
+                      <a:prstDash val="solid"/>
+                      <a:round/>
+                      <a:headEnd type="none" w="med" len="med"/>
+                      <a:tailEnd type="none" w="med" len="med"/>
+                    </a:lnR>
+                    <a:lnT w="3175" cap="flat" cmpd="sng" algn="ctr">
+                      <a:solidFill>
+                        <a:schemeClr val="bg1">
+                          <a:lumMod val="65000"/>
+                        </a:schemeClr>
+                      </a:solidFill>
+                      <a:prstDash val="solid"/>
+                      <a:round/>
+                      <a:headEnd type="none" w="med" len="med"/>
+                      <a:tailEnd type="none" w="med" len="med"/>
+                    </a:lnT>
+                    <a:lnB w="3175" cap="flat" cmpd="sng" algn="ctr">
+                      <a:solidFill>
+                        <a:schemeClr val="bg1">
+                          <a:lumMod val="65000"/>
+                        </a:schemeClr>
+                      </a:solidFill>
+                      <a:prstDash val="solid"/>
+                      <a:round/>
+                      <a:headEnd type="none" w="med" len="med"/>
+                      <a:tailEnd type="none" w="med" len="med"/>
+                    </a:lnB>
+                  </a:tcPr>
+                </a:tc>
+                <a:extLst>
+                  <a:ext uri="{0D108BD9-81ED-4DB2-BD59-A6C34878D82A}">
+                    <a16:rowId xmlns:a16="http://schemas.microsoft.com/office/drawing/2014/main" val="2280979640"/>
+                  </a:ext>
+                </a:extLst>
+              </a:tr>
+              <a:tr h="106163">
+                <a:tc>
+                  <a:txBody>
+                    <a:bodyPr/>
+                    <a:lstStyle/>
+                    <a:p>
+                      <a:pPr algn="ctr" fontAlgn="b">
+                        <a:buNone/>
+                      </a:pPr>
+                      <a:r>
+                        <a:rPr lang="en-CA" sz="1200" b="0" i="0" u="none" strike="noStrike" dirty="0">
+                          <a:solidFill>
+                            <a:srgbClr val="000000"/>
+                          </a:solidFill>
+                          <a:effectLst/>
+                          <a:latin typeface="Courier New" panose="02070309020205020404" pitchFamily="49" charset="0"/>
+                          <a:cs typeface="Courier New" panose="02070309020205020404" pitchFamily="49" charset="0"/>
+                        </a:rPr>
+                        <a:t>40705877</a:t>
+                      </a:r>
+                    </a:p>
+                  </a:txBody>
+                  <a:tcPr marL="6350" marR="6350" marT="6350" marB="0" anchor="b">
+                    <a:lnL w="6350" cap="flat" cmpd="sng" algn="ctr">
+                      <a:solidFill>
+                        <a:schemeClr val="tx1">
+                          <a:lumMod val="95000"/>
+                          <a:lumOff val="5000"/>
+                        </a:schemeClr>
+                      </a:solidFill>
+                      <a:prstDash val="solid"/>
+                      <a:round/>
+                      <a:headEnd type="none" w="med" len="med"/>
+                      <a:tailEnd type="none" w="med" len="med"/>
+                    </a:lnL>
+                    <a:lnR w="3175" cap="flat" cmpd="sng" algn="ctr">
+                      <a:solidFill>
+                        <a:schemeClr val="bg1">
+                          <a:lumMod val="65000"/>
+                        </a:schemeClr>
+                      </a:solidFill>
+                      <a:prstDash val="solid"/>
+                      <a:round/>
+                      <a:headEnd type="none" w="med" len="med"/>
+                      <a:tailEnd type="none" w="med" len="med"/>
+                    </a:lnR>
+                    <a:lnT w="3175" cap="flat" cmpd="sng" algn="ctr">
+                      <a:solidFill>
+                        <a:schemeClr val="bg1">
+                          <a:lumMod val="65000"/>
+                        </a:schemeClr>
+                      </a:solidFill>
+                      <a:prstDash val="solid"/>
+                      <a:round/>
+                      <a:headEnd type="none" w="med" len="med"/>
+                      <a:tailEnd type="none" w="med" len="med"/>
+                    </a:lnT>
+                    <a:lnB w="3175" cap="flat" cmpd="sng" algn="ctr">
+                      <a:solidFill>
+                        <a:schemeClr val="bg1">
+                          <a:lumMod val="65000"/>
+                        </a:schemeClr>
+                      </a:solidFill>
+                      <a:prstDash val="solid"/>
+                      <a:round/>
+                      <a:headEnd type="none" w="med" len="med"/>
+                      <a:tailEnd type="none" w="med" len="med"/>
+                    </a:lnB>
+                  </a:tcPr>
+                </a:tc>
+                <a:tc>
+                  <a:txBody>
+                    <a:bodyPr/>
+                    <a:lstStyle/>
+                    <a:p>
+                      <a:pPr algn="ctr" fontAlgn="b">
+                        <a:buNone/>
+                      </a:pPr>
+                      <a:r>
+                        <a:rPr lang="en-CA" sz="1200" b="0" i="0" u="none" strike="noStrike" dirty="0">
+                          <a:solidFill>
+                            <a:srgbClr val="000000"/>
+                          </a:solidFill>
+                          <a:effectLst/>
+                          <a:latin typeface="Courier New" panose="02070309020205020404" pitchFamily="49" charset="0"/>
+                          <a:cs typeface="Courier New" panose="02070309020205020404" pitchFamily="49" charset="0"/>
+                        </a:rPr>
+                        <a:t>ThsA</a:t>
+                      </a:r>
+                    </a:p>
+                  </a:txBody>
+                  <a:tcPr marL="6350" marR="6350" marT="6350" marB="0" anchor="b">
+                    <a:lnL w="3175" cap="flat" cmpd="sng" algn="ctr">
+                      <a:solidFill>
+                        <a:schemeClr val="bg1">
+                          <a:lumMod val="65000"/>
+                        </a:schemeClr>
+                      </a:solidFill>
+                      <a:prstDash val="solid"/>
+                      <a:round/>
+                      <a:headEnd type="none" w="med" len="med"/>
+                      <a:tailEnd type="none" w="med" len="med"/>
+                    </a:lnL>
+                    <a:lnR w="3175" cap="flat" cmpd="sng" algn="ctr">
+                      <a:solidFill>
+                        <a:schemeClr val="bg1">
+                          <a:lumMod val="65000"/>
+                        </a:schemeClr>
+                      </a:solidFill>
+                      <a:prstDash val="solid"/>
+                      <a:round/>
+                      <a:headEnd type="none" w="med" len="med"/>
+                      <a:tailEnd type="none" w="med" len="med"/>
+                    </a:lnR>
+                    <a:lnT w="3175" cap="flat" cmpd="sng" algn="ctr">
+                      <a:solidFill>
+                        <a:schemeClr val="bg1">
+                          <a:lumMod val="65000"/>
+                        </a:schemeClr>
+                      </a:solidFill>
+                      <a:prstDash val="solid"/>
+                      <a:round/>
+                      <a:headEnd type="none" w="med" len="med"/>
+                      <a:tailEnd type="none" w="med" len="med"/>
+                    </a:lnT>
+                    <a:lnB w="3175" cap="flat" cmpd="sng" algn="ctr">
+                      <a:solidFill>
+                        <a:schemeClr val="bg1">
+                          <a:lumMod val="65000"/>
+                        </a:schemeClr>
+                      </a:solidFill>
+                      <a:prstDash val="solid"/>
+                      <a:round/>
+                      <a:headEnd type="none" w="med" len="med"/>
+                      <a:tailEnd type="none" w="med" len="med"/>
+                    </a:lnB>
+                  </a:tcPr>
+                </a:tc>
+                <a:tc>
+                  <a:txBody>
+                    <a:bodyPr/>
+                    <a:lstStyle/>
+                    <a:p>
+                      <a:pPr algn="ctr" fontAlgn="b">
+                        <a:buNone/>
+                      </a:pPr>
+                      <a:r>
+                        <a:rPr lang="en-CA" sz="1200" b="0" i="0" u="none" strike="noStrike">
+                          <a:solidFill>
+                            <a:srgbClr val="000000"/>
+                          </a:solidFill>
+                          <a:effectLst/>
+                          <a:latin typeface="Courier New" panose="02070309020205020404" pitchFamily="49" charset="0"/>
+                          <a:cs typeface="Courier New" panose="02070309020205020404" pitchFamily="49" charset="0"/>
+                        </a:rPr>
+                        <a:t>SIRT2</a:t>
+                      </a:r>
+                    </a:p>
+                  </a:txBody>
+                  <a:tcPr marL="6350" marR="6350" marT="6350" marB="0" anchor="b">
+                    <a:lnL w="3175" cap="flat" cmpd="sng" algn="ctr">
+                      <a:solidFill>
+                        <a:schemeClr val="bg1">
+                          <a:lumMod val="65000"/>
+                        </a:schemeClr>
+                      </a:solidFill>
+                      <a:prstDash val="solid"/>
+                      <a:round/>
+                      <a:headEnd type="none" w="med" len="med"/>
+                      <a:tailEnd type="none" w="med" len="med"/>
+                    </a:lnL>
+                    <a:lnR w="6350" cap="flat" cmpd="sng" algn="ctr">
+                      <a:solidFill>
+                        <a:schemeClr val="tx1">
+                          <a:lumMod val="95000"/>
+                          <a:lumOff val="5000"/>
+                        </a:schemeClr>
+                      </a:solidFill>
+                      <a:prstDash val="solid"/>
+                      <a:round/>
+                      <a:headEnd type="none" w="med" len="med"/>
+                      <a:tailEnd type="none" w="med" len="med"/>
+                    </a:lnR>
+                    <a:lnT w="3175" cap="flat" cmpd="sng" algn="ctr">
+                      <a:solidFill>
+                        <a:schemeClr val="bg1">
+                          <a:lumMod val="65000"/>
+                        </a:schemeClr>
+                      </a:solidFill>
+                      <a:prstDash val="solid"/>
+                      <a:round/>
+                      <a:headEnd type="none" w="med" len="med"/>
+                      <a:tailEnd type="none" w="med" len="med"/>
+                    </a:lnT>
+                    <a:lnB w="3175" cap="flat" cmpd="sng" algn="ctr">
+                      <a:solidFill>
+                        <a:schemeClr val="bg1">
+                          <a:lumMod val="65000"/>
+                        </a:schemeClr>
+                      </a:solidFill>
+                      <a:prstDash val="solid"/>
+                      <a:round/>
+                      <a:headEnd type="none" w="med" len="med"/>
+                      <a:tailEnd type="none" w="med" len="med"/>
+                    </a:lnB>
+                  </a:tcPr>
+                </a:tc>
+                <a:extLst>
+                  <a:ext uri="{0D108BD9-81ED-4DB2-BD59-A6C34878D82A}">
+                    <a16:rowId xmlns:a16="http://schemas.microsoft.com/office/drawing/2014/main" val="850362416"/>
+                  </a:ext>
+                </a:extLst>
+              </a:tr>
+              <a:tr h="106163">
+                <a:tc>
+                  <a:txBody>
+                    <a:bodyPr/>
+                    <a:lstStyle/>
+                    <a:p>
+                      <a:pPr algn="ctr" fontAlgn="b">
+                        <a:buNone/>
+                      </a:pPr>
+                      <a:r>
+                        <a:rPr lang="en-CA" sz="1200" b="0" i="0" u="none" strike="noStrike" dirty="0">
+                          <a:solidFill>
+                            <a:srgbClr val="000000"/>
+                          </a:solidFill>
+                          <a:effectLst/>
+                          <a:latin typeface="Courier New" panose="02070309020205020404" pitchFamily="49" charset="0"/>
+                          <a:cs typeface="Courier New" panose="02070309020205020404" pitchFamily="49" charset="0"/>
+                        </a:rPr>
+                        <a:t>40705877</a:t>
+                      </a:r>
+                    </a:p>
+                  </a:txBody>
+                  <a:tcPr marL="6350" marR="6350" marT="6350" marB="0" anchor="b">
+                    <a:lnL w="6350" cap="flat" cmpd="sng" algn="ctr">
+                      <a:solidFill>
+                        <a:schemeClr val="tx1">
+                          <a:lumMod val="95000"/>
+                          <a:lumOff val="5000"/>
+                        </a:schemeClr>
+                      </a:solidFill>
+                      <a:prstDash val="solid"/>
+                      <a:round/>
+                      <a:headEnd type="none" w="med" len="med"/>
+                      <a:tailEnd type="none" w="med" len="med"/>
+                    </a:lnL>
+                    <a:lnR w="3175" cap="flat" cmpd="sng" algn="ctr">
+                      <a:solidFill>
+                        <a:schemeClr val="bg1">
+                          <a:lumMod val="65000"/>
+                        </a:schemeClr>
+                      </a:solidFill>
+                      <a:prstDash val="solid"/>
+                      <a:round/>
+                      <a:headEnd type="none" w="med" len="med"/>
+                      <a:tailEnd type="none" w="med" len="med"/>
+                    </a:lnR>
+                    <a:lnT w="3175" cap="flat" cmpd="sng" algn="ctr">
+                      <a:solidFill>
+                        <a:schemeClr val="bg1">
+                          <a:lumMod val="65000"/>
+                        </a:schemeClr>
+                      </a:solidFill>
+                      <a:prstDash val="solid"/>
+                      <a:round/>
+                      <a:headEnd type="none" w="med" len="med"/>
+                      <a:tailEnd type="none" w="med" len="med"/>
+                    </a:lnT>
+                    <a:lnB w="3175" cap="flat" cmpd="sng" algn="ctr">
+                      <a:solidFill>
+                        <a:schemeClr val="bg1">
+                          <a:lumMod val="65000"/>
+                        </a:schemeClr>
+                      </a:solidFill>
+                      <a:prstDash val="solid"/>
+                      <a:round/>
+                      <a:headEnd type="none" w="med" len="med"/>
+                      <a:tailEnd type="none" w="med" len="med"/>
+                    </a:lnB>
+                  </a:tcPr>
+                </a:tc>
+                <a:tc>
+                  <a:txBody>
+                    <a:bodyPr/>
+                    <a:lstStyle/>
+                    <a:p>
+                      <a:pPr algn="ctr" fontAlgn="b">
+                        <a:buNone/>
+                      </a:pPr>
+                      <a:r>
+                        <a:rPr lang="en-CA" sz="1200" b="0" i="0" u="none" strike="noStrike" dirty="0">
+                          <a:solidFill>
+                            <a:srgbClr val="000000"/>
+                          </a:solidFill>
+                          <a:effectLst/>
+                          <a:latin typeface="Courier New" panose="02070309020205020404" pitchFamily="49" charset="0"/>
+                          <a:cs typeface="Courier New" panose="02070309020205020404" pitchFamily="49" charset="0"/>
+                        </a:rPr>
+                        <a:t>ThsA</a:t>
+                      </a:r>
+                    </a:p>
+                  </a:txBody>
+                  <a:tcPr marL="6350" marR="6350" marT="6350" marB="0" anchor="b">
+                    <a:lnL w="3175" cap="flat" cmpd="sng" algn="ctr">
+                      <a:solidFill>
+                        <a:schemeClr val="bg1">
+                          <a:lumMod val="65000"/>
+                        </a:schemeClr>
+                      </a:solidFill>
+                      <a:prstDash val="solid"/>
+                      <a:round/>
+                      <a:headEnd type="none" w="med" len="med"/>
+                      <a:tailEnd type="none" w="med" len="med"/>
+                    </a:lnL>
+                    <a:lnR w="3175" cap="flat" cmpd="sng" algn="ctr">
+                      <a:solidFill>
+                        <a:schemeClr val="bg1">
+                          <a:lumMod val="65000"/>
+                        </a:schemeClr>
+                      </a:solidFill>
+                      <a:prstDash val="solid"/>
+                      <a:round/>
+                      <a:headEnd type="none" w="med" len="med"/>
+                      <a:tailEnd type="none" w="med" len="med"/>
+                    </a:lnR>
+                    <a:lnT w="3175" cap="flat" cmpd="sng" algn="ctr">
+                      <a:solidFill>
+                        <a:schemeClr val="bg1">
+                          <a:lumMod val="65000"/>
+                        </a:schemeClr>
+                      </a:solidFill>
+                      <a:prstDash val="solid"/>
+                      <a:round/>
+                      <a:headEnd type="none" w="med" len="med"/>
+                      <a:tailEnd type="none" w="med" len="med"/>
+                    </a:lnT>
+                    <a:lnB w="3175" cap="flat" cmpd="sng" algn="ctr">
+                      <a:solidFill>
+                        <a:schemeClr val="bg1">
+                          <a:lumMod val="65000"/>
+                        </a:schemeClr>
+                      </a:solidFill>
+                      <a:prstDash val="solid"/>
+                      <a:round/>
+                      <a:headEnd type="none" w="med" len="med"/>
+                      <a:tailEnd type="none" w="med" len="med"/>
+                    </a:lnB>
+                  </a:tcPr>
+                </a:tc>
+                <a:tc>
+                  <a:txBody>
+                    <a:bodyPr/>
+                    <a:lstStyle/>
+                    <a:p>
+                      <a:pPr algn="ctr" fontAlgn="b">
+                        <a:buNone/>
+                      </a:pPr>
+                      <a:r>
+                        <a:rPr lang="en-CA" sz="1200" b="0" i="0" u="none" strike="noStrike">
+                          <a:solidFill>
+                            <a:srgbClr val="000000"/>
+                          </a:solidFill>
+                          <a:effectLst/>
+                          <a:latin typeface="Courier New" panose="02070309020205020404" pitchFamily="49" charset="0"/>
+                          <a:cs typeface="Courier New" panose="02070309020205020404" pitchFamily="49" charset="0"/>
+                        </a:rPr>
+                        <a:t>SIRT4</a:t>
+                      </a:r>
+                    </a:p>
+                  </a:txBody>
+                  <a:tcPr marL="6350" marR="6350" marT="6350" marB="0" anchor="b">
+                    <a:lnL w="3175" cap="flat" cmpd="sng" algn="ctr">
+                      <a:solidFill>
+                        <a:schemeClr val="bg1">
+                          <a:lumMod val="65000"/>
+                        </a:schemeClr>
+                      </a:solidFill>
+                      <a:prstDash val="solid"/>
+                      <a:round/>
+                      <a:headEnd type="none" w="med" len="med"/>
+                      <a:tailEnd type="none" w="med" len="med"/>
+                    </a:lnL>
+                    <a:lnR w="6350" cap="flat" cmpd="sng" algn="ctr">
+                      <a:solidFill>
+                        <a:schemeClr val="tx1">
+                          <a:lumMod val="95000"/>
+                          <a:lumOff val="5000"/>
+                        </a:schemeClr>
+                      </a:solidFill>
+                      <a:prstDash val="solid"/>
+                      <a:round/>
+                      <a:headEnd type="none" w="med" len="med"/>
+                      <a:tailEnd type="none" w="med" len="med"/>
+                    </a:lnR>
+                    <a:lnT w="3175" cap="flat" cmpd="sng" algn="ctr">
+                      <a:solidFill>
+                        <a:schemeClr val="bg1">
+                          <a:lumMod val="65000"/>
+                        </a:schemeClr>
+                      </a:solidFill>
+                      <a:prstDash val="solid"/>
+                      <a:round/>
+                      <a:headEnd type="none" w="med" len="med"/>
+                      <a:tailEnd type="none" w="med" len="med"/>
+                    </a:lnT>
+                    <a:lnB w="3175" cap="flat" cmpd="sng" algn="ctr">
+                      <a:solidFill>
+                        <a:schemeClr val="bg1">
+                          <a:lumMod val="65000"/>
+                        </a:schemeClr>
+                      </a:solidFill>
+                      <a:prstDash val="solid"/>
+                      <a:round/>
+                      <a:headEnd type="none" w="med" len="med"/>
+                      <a:tailEnd type="none" w="med" len="med"/>
+                    </a:lnB>
+                  </a:tcPr>
+                </a:tc>
+                <a:extLst>
+                  <a:ext uri="{0D108BD9-81ED-4DB2-BD59-A6C34878D82A}">
+                    <a16:rowId xmlns:a16="http://schemas.microsoft.com/office/drawing/2014/main" val="1845554006"/>
+                  </a:ext>
+                </a:extLst>
+              </a:tr>
+              <a:tr h="106163">
+                <a:tc>
+                  <a:txBody>
+                    <a:bodyPr/>
+                    <a:lstStyle/>
+                    <a:p>
+                      <a:pPr algn="ctr" fontAlgn="b">
+                        <a:buNone/>
+                      </a:pPr>
+                      <a:r>
+                        <a:rPr lang="en-CA" sz="1200" b="0" i="0" u="none" strike="noStrike" dirty="0">
+                          <a:solidFill>
+                            <a:srgbClr val="000000"/>
+                          </a:solidFill>
+                          <a:effectLst/>
+                          <a:latin typeface="Courier New" panose="02070309020205020404" pitchFamily="49" charset="0"/>
+                          <a:cs typeface="Courier New" panose="02070309020205020404" pitchFamily="49" charset="0"/>
+                        </a:rPr>
+                        <a:t>40705877</a:t>
+                      </a:r>
+                    </a:p>
+                  </a:txBody>
+                  <a:tcPr marL="6350" marR="6350" marT="6350" marB="0" anchor="b">
+                    <a:lnL w="6350" cap="flat" cmpd="sng" algn="ctr">
+                      <a:solidFill>
+                        <a:schemeClr val="tx1">
+                          <a:lumMod val="95000"/>
+                          <a:lumOff val="5000"/>
+                        </a:schemeClr>
+                      </a:solidFill>
+                      <a:prstDash val="solid"/>
+                      <a:round/>
+                      <a:headEnd type="none" w="med" len="med"/>
+                      <a:tailEnd type="none" w="med" len="med"/>
+                    </a:lnL>
+                    <a:lnR w="3175" cap="flat" cmpd="sng" algn="ctr">
+                      <a:solidFill>
+                        <a:schemeClr val="bg1">
+                          <a:lumMod val="65000"/>
+                        </a:schemeClr>
+                      </a:solidFill>
+                      <a:prstDash val="solid"/>
+                      <a:round/>
+                      <a:headEnd type="none" w="med" len="med"/>
+                      <a:tailEnd type="none" w="med" len="med"/>
+                    </a:lnR>
+                    <a:lnT w="3175" cap="flat" cmpd="sng" algn="ctr">
+                      <a:solidFill>
+                        <a:schemeClr val="bg1">
+                          <a:lumMod val="65000"/>
+                        </a:schemeClr>
+                      </a:solidFill>
+                      <a:prstDash val="solid"/>
+                      <a:round/>
+                      <a:headEnd type="none" w="med" len="med"/>
+                      <a:tailEnd type="none" w="med" len="med"/>
+                    </a:lnT>
+                    <a:lnB w="3175" cap="flat" cmpd="sng" algn="ctr">
+                      <a:solidFill>
+                        <a:schemeClr val="bg1">
+                          <a:lumMod val="65000"/>
+                        </a:schemeClr>
+                      </a:solidFill>
+                      <a:prstDash val="solid"/>
+                      <a:round/>
+                      <a:headEnd type="none" w="med" len="med"/>
+                      <a:tailEnd type="none" w="med" len="med"/>
+                    </a:lnB>
+                  </a:tcPr>
+                </a:tc>
+                <a:tc>
+                  <a:txBody>
+                    <a:bodyPr/>
+                    <a:lstStyle/>
+                    <a:p>
+                      <a:pPr algn="ctr" fontAlgn="b">
+                        <a:buNone/>
+                      </a:pPr>
+                      <a:r>
+                        <a:rPr lang="en-CA" sz="1200" b="0" i="0" u="none" strike="noStrike" dirty="0">
+                          <a:solidFill>
+                            <a:srgbClr val="000000"/>
+                          </a:solidFill>
+                          <a:effectLst/>
+                          <a:latin typeface="Courier New" panose="02070309020205020404" pitchFamily="49" charset="0"/>
+                          <a:cs typeface="Courier New" panose="02070309020205020404" pitchFamily="49" charset="0"/>
+                        </a:rPr>
+                        <a:t>ThsA</a:t>
+                      </a:r>
+                    </a:p>
+                  </a:txBody>
+                  <a:tcPr marL="6350" marR="6350" marT="6350" marB="0" anchor="b">
+                    <a:lnL w="3175" cap="flat" cmpd="sng" algn="ctr">
+                      <a:solidFill>
+                        <a:schemeClr val="bg1">
+                          <a:lumMod val="65000"/>
+                        </a:schemeClr>
+                      </a:solidFill>
+                      <a:prstDash val="solid"/>
+                      <a:round/>
+                      <a:headEnd type="none" w="med" len="med"/>
+                      <a:tailEnd type="none" w="med" len="med"/>
+                    </a:lnL>
+                    <a:lnR w="3175" cap="flat" cmpd="sng" algn="ctr">
+                      <a:solidFill>
+                        <a:schemeClr val="bg1">
+                          <a:lumMod val="65000"/>
+                        </a:schemeClr>
+                      </a:solidFill>
+                      <a:prstDash val="solid"/>
+                      <a:round/>
+                      <a:headEnd type="none" w="med" len="med"/>
+                      <a:tailEnd type="none" w="med" len="med"/>
+                    </a:lnR>
+                    <a:lnT w="3175" cap="flat" cmpd="sng" algn="ctr">
+                      <a:solidFill>
+                        <a:schemeClr val="bg1">
+                          <a:lumMod val="65000"/>
+                        </a:schemeClr>
+                      </a:solidFill>
+                      <a:prstDash val="solid"/>
+                      <a:round/>
+                      <a:headEnd type="none" w="med" len="med"/>
+                      <a:tailEnd type="none" w="med" len="med"/>
+                    </a:lnT>
+                    <a:lnB w="3175" cap="flat" cmpd="sng" algn="ctr">
+                      <a:solidFill>
+                        <a:schemeClr val="bg1">
+                          <a:lumMod val="65000"/>
+                        </a:schemeClr>
+                      </a:solidFill>
+                      <a:prstDash val="solid"/>
+                      <a:round/>
+                      <a:headEnd type="none" w="med" len="med"/>
+                      <a:tailEnd type="none" w="med" len="med"/>
+                    </a:lnB>
+                  </a:tcPr>
+                </a:tc>
+                <a:tc>
+                  <a:txBody>
+                    <a:bodyPr/>
+                    <a:lstStyle/>
+                    <a:p>
+                      <a:pPr algn="ctr" fontAlgn="b">
+                        <a:buNone/>
+                      </a:pPr>
+                      <a:r>
+                        <a:rPr lang="en-CA" sz="1200" b="0" i="0" u="none" strike="noStrike" dirty="0">
+                          <a:solidFill>
+                            <a:srgbClr val="000000"/>
+                          </a:solidFill>
+                          <a:effectLst/>
+                          <a:latin typeface="Courier New" panose="02070309020205020404" pitchFamily="49" charset="0"/>
+                          <a:cs typeface="Courier New" panose="02070309020205020404" pitchFamily="49" charset="0"/>
+                        </a:rPr>
+                        <a:t>SIRT5</a:t>
+                      </a:r>
+                    </a:p>
+                  </a:txBody>
+                  <a:tcPr marL="6350" marR="6350" marT="6350" marB="0" anchor="b">
+                    <a:lnL w="3175" cap="flat" cmpd="sng" algn="ctr">
+                      <a:solidFill>
+                        <a:schemeClr val="bg1">
+                          <a:lumMod val="65000"/>
+                        </a:schemeClr>
+                      </a:solidFill>
+                      <a:prstDash val="solid"/>
+                      <a:round/>
+                      <a:headEnd type="none" w="med" len="med"/>
+                      <a:tailEnd type="none" w="med" len="med"/>
+                    </a:lnL>
+                    <a:lnR w="6350" cap="flat" cmpd="sng" algn="ctr">
+                      <a:solidFill>
+                        <a:schemeClr val="tx1">
+                          <a:lumMod val="95000"/>
+                          <a:lumOff val="5000"/>
+                        </a:schemeClr>
+                      </a:solidFill>
+                      <a:prstDash val="solid"/>
+                      <a:round/>
+                      <a:headEnd type="none" w="med" len="med"/>
+                      <a:tailEnd type="none" w="med" len="med"/>
+                    </a:lnR>
+                    <a:lnT w="3175" cap="flat" cmpd="sng" algn="ctr">
+                      <a:solidFill>
+                        <a:schemeClr val="bg1">
+                          <a:lumMod val="65000"/>
+                        </a:schemeClr>
+                      </a:solidFill>
+                      <a:prstDash val="solid"/>
+                      <a:round/>
+                      <a:headEnd type="none" w="med" len="med"/>
+                      <a:tailEnd type="none" w="med" len="med"/>
+                    </a:lnT>
+                    <a:lnB w="3175" cap="flat" cmpd="sng" algn="ctr">
+                      <a:solidFill>
+                        <a:schemeClr val="bg1">
+                          <a:lumMod val="65000"/>
+                        </a:schemeClr>
+                      </a:solidFill>
+                      <a:prstDash val="solid"/>
+                      <a:round/>
+                      <a:headEnd type="none" w="med" len="med"/>
+                      <a:tailEnd type="none" w="med" len="med"/>
+                    </a:lnB>
+                  </a:tcPr>
+                </a:tc>
+                <a:extLst>
+                  <a:ext uri="{0D108BD9-81ED-4DB2-BD59-A6C34878D82A}">
+                    <a16:rowId xmlns:a16="http://schemas.microsoft.com/office/drawing/2014/main" val="3268022963"/>
+                  </a:ext>
+                </a:extLst>
+              </a:tr>
+              <a:tr h="106163">
+                <a:tc>
+                  <a:txBody>
+                    <a:bodyPr/>
+                    <a:lstStyle/>
+                    <a:p>
+                      <a:pPr algn="ctr" fontAlgn="b">
+                        <a:buNone/>
+                      </a:pPr>
+                      <a:r>
+                        <a:rPr lang="en-CA" sz="1200" b="0" i="0" u="none" strike="noStrike" dirty="0">
+                          <a:solidFill>
+                            <a:srgbClr val="000000"/>
+                          </a:solidFill>
+                          <a:effectLst/>
+                          <a:latin typeface="Courier New" panose="02070309020205020404" pitchFamily="49" charset="0"/>
+                          <a:cs typeface="Courier New" panose="02070309020205020404" pitchFamily="49" charset="0"/>
+                        </a:rPr>
+                        <a:t>40705877</a:t>
+                      </a:r>
+                    </a:p>
+                  </a:txBody>
+                  <a:tcPr marL="6350" marR="6350" marT="6350" marB="0" anchor="b">
+                    <a:lnL w="6350" cap="flat" cmpd="sng" algn="ctr">
+                      <a:solidFill>
+                        <a:schemeClr val="tx1">
+                          <a:lumMod val="95000"/>
+                          <a:lumOff val="5000"/>
+                        </a:schemeClr>
+                      </a:solidFill>
+                      <a:prstDash val="solid"/>
+                      <a:round/>
+                      <a:headEnd type="none" w="med" len="med"/>
+                      <a:tailEnd type="none" w="med" len="med"/>
+                    </a:lnL>
+                    <a:lnR w="3175" cap="flat" cmpd="sng" algn="ctr">
+                      <a:solidFill>
+                        <a:schemeClr val="bg1">
+                          <a:lumMod val="65000"/>
+                        </a:schemeClr>
+                      </a:solidFill>
+                      <a:prstDash val="solid"/>
+                      <a:round/>
+                      <a:headEnd type="none" w="med" len="med"/>
+                      <a:tailEnd type="none" w="med" len="med"/>
+                    </a:lnR>
+                    <a:lnT w="3175" cap="flat" cmpd="sng" algn="ctr">
+                      <a:solidFill>
+                        <a:schemeClr val="bg1">
+                          <a:lumMod val="65000"/>
+                        </a:schemeClr>
+                      </a:solidFill>
+                      <a:prstDash val="solid"/>
+                      <a:round/>
+                      <a:headEnd type="none" w="med" len="med"/>
+                      <a:tailEnd type="none" w="med" len="med"/>
+                    </a:lnT>
+                    <a:lnB w="3175" cap="flat" cmpd="sng" algn="ctr">
+                      <a:solidFill>
+                        <a:schemeClr val="bg1">
+                          <a:lumMod val="65000"/>
+                        </a:schemeClr>
+                      </a:solidFill>
+                      <a:prstDash val="solid"/>
+                      <a:round/>
+                      <a:headEnd type="none" w="med" len="med"/>
+                      <a:tailEnd type="none" w="med" len="med"/>
+                    </a:lnB>
+                  </a:tcPr>
+                </a:tc>
+                <a:tc>
+                  <a:txBody>
+                    <a:bodyPr/>
+                    <a:lstStyle/>
+                    <a:p>
+                      <a:pPr algn="ctr" fontAlgn="b">
+                        <a:buNone/>
+                      </a:pPr>
+                      <a:r>
+                        <a:rPr lang="en-CA" sz="1200" b="0" i="0" u="none" strike="noStrike" dirty="0">
+                          <a:solidFill>
+                            <a:srgbClr val="000000"/>
+                          </a:solidFill>
+                          <a:effectLst/>
+                          <a:latin typeface="Courier New" panose="02070309020205020404" pitchFamily="49" charset="0"/>
+                          <a:cs typeface="Courier New" panose="02070309020205020404" pitchFamily="49" charset="0"/>
+                        </a:rPr>
+                        <a:t>ThsA</a:t>
+                      </a:r>
+                    </a:p>
+                  </a:txBody>
+                  <a:tcPr marL="6350" marR="6350" marT="6350" marB="0" anchor="b">
+                    <a:lnL w="3175" cap="flat" cmpd="sng" algn="ctr">
+                      <a:solidFill>
+                        <a:schemeClr val="bg1">
+                          <a:lumMod val="65000"/>
+                        </a:schemeClr>
+                      </a:solidFill>
+                      <a:prstDash val="solid"/>
+                      <a:round/>
+                      <a:headEnd type="none" w="med" len="med"/>
+                      <a:tailEnd type="none" w="med" len="med"/>
+                    </a:lnL>
+                    <a:lnR w="3175" cap="flat" cmpd="sng" algn="ctr">
+                      <a:solidFill>
+                        <a:schemeClr val="bg1">
+                          <a:lumMod val="65000"/>
+                        </a:schemeClr>
+                      </a:solidFill>
+                      <a:prstDash val="solid"/>
+                      <a:round/>
+                      <a:headEnd type="none" w="med" len="med"/>
+                      <a:tailEnd type="none" w="med" len="med"/>
+                    </a:lnR>
+                    <a:lnT w="3175" cap="flat" cmpd="sng" algn="ctr">
+                      <a:solidFill>
+                        <a:schemeClr val="bg1">
+                          <a:lumMod val="65000"/>
+                        </a:schemeClr>
+                      </a:solidFill>
+                      <a:prstDash val="solid"/>
+                      <a:round/>
+                      <a:headEnd type="none" w="med" len="med"/>
+                      <a:tailEnd type="none" w="med" len="med"/>
+                    </a:lnT>
+                    <a:lnB w="3175" cap="flat" cmpd="sng" algn="ctr">
+                      <a:solidFill>
+                        <a:schemeClr val="bg1">
+                          <a:lumMod val="65000"/>
+                        </a:schemeClr>
+                      </a:solidFill>
+                      <a:prstDash val="solid"/>
+                      <a:round/>
+                      <a:headEnd type="none" w="med" len="med"/>
+                      <a:tailEnd type="none" w="med" len="med"/>
+                    </a:lnB>
+                  </a:tcPr>
+                </a:tc>
+                <a:tc>
+                  <a:txBody>
+                    <a:bodyPr/>
+                    <a:lstStyle/>
+                    <a:p>
+                      <a:pPr algn="ctr" fontAlgn="b">
+                        <a:buNone/>
+                      </a:pPr>
+                      <a:r>
+                        <a:rPr lang="en-CA" sz="1200" b="0" i="0" u="none" strike="noStrike" dirty="0">
+                          <a:solidFill>
+                            <a:srgbClr val="000000"/>
+                          </a:solidFill>
+                          <a:effectLst/>
+                          <a:latin typeface="Courier New" panose="02070309020205020404" pitchFamily="49" charset="0"/>
+                          <a:cs typeface="Courier New" panose="02070309020205020404" pitchFamily="49" charset="0"/>
+                        </a:rPr>
+                        <a:t>SIRT6</a:t>
+                      </a:r>
+                    </a:p>
+                  </a:txBody>
+                  <a:tcPr marL="6350" marR="6350" marT="6350" marB="0" anchor="b">
+                    <a:lnL w="3175" cap="flat" cmpd="sng" algn="ctr">
+                      <a:solidFill>
+                        <a:schemeClr val="bg1">
+                          <a:lumMod val="65000"/>
+                        </a:schemeClr>
+                      </a:solidFill>
+                      <a:prstDash val="solid"/>
+                      <a:round/>
+                      <a:headEnd type="none" w="med" len="med"/>
+                      <a:tailEnd type="none" w="med" len="med"/>
+                    </a:lnL>
+                    <a:lnR w="6350" cap="flat" cmpd="sng" algn="ctr">
+                      <a:solidFill>
+                        <a:schemeClr val="tx1">
+                          <a:lumMod val="95000"/>
+                          <a:lumOff val="5000"/>
+                        </a:schemeClr>
+                      </a:solidFill>
+                      <a:prstDash val="solid"/>
+                      <a:round/>
+                      <a:headEnd type="none" w="med" len="med"/>
+                      <a:tailEnd type="none" w="med" len="med"/>
+                    </a:lnR>
+                    <a:lnT w="3175" cap="flat" cmpd="sng" algn="ctr">
+                      <a:solidFill>
+                        <a:schemeClr val="bg1">
+                          <a:lumMod val="65000"/>
+                        </a:schemeClr>
+                      </a:solidFill>
+                      <a:prstDash val="solid"/>
+                      <a:round/>
+                      <a:headEnd type="none" w="med" len="med"/>
+                      <a:tailEnd type="none" w="med" len="med"/>
+                    </a:lnT>
+                    <a:lnB w="3175" cap="flat" cmpd="sng" algn="ctr">
+                      <a:solidFill>
+                        <a:schemeClr val="bg1">
+                          <a:lumMod val="65000"/>
+                        </a:schemeClr>
+                      </a:solidFill>
+                      <a:prstDash val="solid"/>
+                      <a:round/>
+                      <a:headEnd type="none" w="med" len="med"/>
+                      <a:tailEnd type="none" w="med" len="med"/>
+                    </a:lnB>
+                  </a:tcPr>
+                </a:tc>
+                <a:extLst>
+                  <a:ext uri="{0D108BD9-81ED-4DB2-BD59-A6C34878D82A}">
+                    <a16:rowId xmlns:a16="http://schemas.microsoft.com/office/drawing/2014/main" val="1854113074"/>
+                  </a:ext>
+                </a:extLst>
+              </a:tr>
+              <a:tr h="106163">
+                <a:tc>
+                  <a:txBody>
+                    <a:bodyPr/>
+                    <a:lstStyle/>
+                    <a:p>
+                      <a:pPr algn="ctr" fontAlgn="b">
+                        <a:buNone/>
+                      </a:pPr>
+                      <a:r>
+                        <a:rPr lang="en-CA" sz="1200" b="0" i="0" u="none" strike="noStrike">
+                          <a:solidFill>
+                            <a:srgbClr val="000000"/>
+                          </a:solidFill>
+                          <a:effectLst/>
+                          <a:latin typeface="Courier New" panose="02070309020205020404" pitchFamily="49" charset="0"/>
+                          <a:cs typeface="Courier New" panose="02070309020205020404" pitchFamily="49" charset="0"/>
+                        </a:rPr>
+                        <a:t>40705877</a:t>
+                      </a:r>
+                    </a:p>
+                  </a:txBody>
+                  <a:tcPr marL="6350" marR="6350" marT="6350" marB="0" anchor="b">
+                    <a:lnL w="6350" cap="flat" cmpd="sng" algn="ctr">
+                      <a:solidFill>
+                        <a:schemeClr val="tx1">
+                          <a:lumMod val="95000"/>
+                          <a:lumOff val="5000"/>
+                        </a:schemeClr>
+                      </a:solidFill>
+                      <a:prstDash val="solid"/>
+                      <a:round/>
+                      <a:headEnd type="none" w="med" len="med"/>
+                      <a:tailEnd type="none" w="med" len="med"/>
+                    </a:lnL>
+                    <a:lnR w="3175" cap="flat" cmpd="sng" algn="ctr">
+                      <a:solidFill>
+                        <a:schemeClr val="bg1">
+                          <a:lumMod val="65000"/>
+                        </a:schemeClr>
+                      </a:solidFill>
+                      <a:prstDash val="solid"/>
+                      <a:round/>
+                      <a:headEnd type="none" w="med" len="med"/>
+                      <a:tailEnd type="none" w="med" len="med"/>
+                    </a:lnR>
+                    <a:lnT w="3175" cap="flat" cmpd="sng" algn="ctr">
+                      <a:solidFill>
+                        <a:schemeClr val="bg1">
+                          <a:lumMod val="65000"/>
+                        </a:schemeClr>
+                      </a:solidFill>
+                      <a:prstDash val="solid"/>
+                      <a:round/>
+                      <a:headEnd type="none" w="med" len="med"/>
+                      <a:tailEnd type="none" w="med" len="med"/>
+                    </a:lnT>
+                    <a:lnB w="3175" cap="flat" cmpd="sng" algn="ctr">
+                      <a:solidFill>
+                        <a:schemeClr val="bg1">
+                          <a:lumMod val="65000"/>
+                        </a:schemeClr>
+                      </a:solidFill>
+                      <a:prstDash val="solid"/>
+                      <a:round/>
+                      <a:headEnd type="none" w="med" len="med"/>
+                      <a:tailEnd type="none" w="med" len="med"/>
+                    </a:lnB>
+                  </a:tcPr>
+                </a:tc>
+                <a:tc>
+                  <a:txBody>
+                    <a:bodyPr/>
+                    <a:lstStyle/>
+                    <a:p>
+                      <a:pPr algn="ctr" fontAlgn="b">
+                        <a:buNone/>
+                      </a:pPr>
+                      <a:r>
+                        <a:rPr lang="en-CA" sz="1200" b="0" i="0" u="none" strike="noStrike" dirty="0">
+                          <a:solidFill>
+                            <a:srgbClr val="000000"/>
+                          </a:solidFill>
+                          <a:effectLst/>
+                          <a:latin typeface="Courier New" panose="02070309020205020404" pitchFamily="49" charset="0"/>
+                          <a:cs typeface="Courier New" panose="02070309020205020404" pitchFamily="49" charset="0"/>
+                        </a:rPr>
+                        <a:t>ThsA</a:t>
+                      </a:r>
+                    </a:p>
+                  </a:txBody>
+                  <a:tcPr marL="6350" marR="6350" marT="6350" marB="0" anchor="b">
+                    <a:lnL w="3175" cap="flat" cmpd="sng" algn="ctr">
+                      <a:solidFill>
+                        <a:schemeClr val="bg1">
+                          <a:lumMod val="65000"/>
+                        </a:schemeClr>
+                      </a:solidFill>
+                      <a:prstDash val="solid"/>
+                      <a:round/>
+                      <a:headEnd type="none" w="med" len="med"/>
+                      <a:tailEnd type="none" w="med" len="med"/>
+                    </a:lnL>
+                    <a:lnR w="3175" cap="flat" cmpd="sng" algn="ctr">
+                      <a:solidFill>
+                        <a:schemeClr val="bg1">
+                          <a:lumMod val="65000"/>
+                        </a:schemeClr>
+                      </a:solidFill>
+                      <a:prstDash val="solid"/>
+                      <a:round/>
+                      <a:headEnd type="none" w="med" len="med"/>
+                      <a:tailEnd type="none" w="med" len="med"/>
+                    </a:lnR>
+                    <a:lnT w="3175" cap="flat" cmpd="sng" algn="ctr">
+                      <a:solidFill>
+                        <a:schemeClr val="bg1">
+                          <a:lumMod val="65000"/>
+                        </a:schemeClr>
+                      </a:solidFill>
+                      <a:prstDash val="solid"/>
+                      <a:round/>
+                      <a:headEnd type="none" w="med" len="med"/>
+                      <a:tailEnd type="none" w="med" len="med"/>
+                    </a:lnT>
+                    <a:lnB w="3175" cap="flat" cmpd="sng" algn="ctr">
+                      <a:solidFill>
+                        <a:schemeClr val="bg1">
+                          <a:lumMod val="65000"/>
+                        </a:schemeClr>
+                      </a:solidFill>
+                      <a:prstDash val="solid"/>
+                      <a:round/>
+                      <a:headEnd type="none" w="med" len="med"/>
+                      <a:tailEnd type="none" w="med" len="med"/>
+                    </a:lnB>
+                  </a:tcPr>
+                </a:tc>
+                <a:tc>
+                  <a:txBody>
+                    <a:bodyPr/>
+                    <a:lstStyle/>
+                    <a:p>
+                      <a:pPr algn="ctr" fontAlgn="b">
+                        <a:buNone/>
+                      </a:pPr>
+                      <a:r>
+                        <a:rPr lang="en-CA" sz="1200" b="0" i="0" u="none" strike="noStrike">
+                          <a:solidFill>
+                            <a:srgbClr val="000000"/>
+                          </a:solidFill>
+                          <a:effectLst/>
+                          <a:latin typeface="Courier New" panose="02070309020205020404" pitchFamily="49" charset="0"/>
+                          <a:cs typeface="Courier New" panose="02070309020205020404" pitchFamily="49" charset="0"/>
+                        </a:rPr>
+                        <a:t>SIRT7</a:t>
+                      </a:r>
+                    </a:p>
+                  </a:txBody>
+                  <a:tcPr marL="6350" marR="6350" marT="6350" marB="0" anchor="b">
+                    <a:lnL w="3175" cap="flat" cmpd="sng" algn="ctr">
+                      <a:solidFill>
+                        <a:schemeClr val="bg1">
+                          <a:lumMod val="65000"/>
+                        </a:schemeClr>
+                      </a:solidFill>
+                      <a:prstDash val="solid"/>
+                      <a:round/>
+                      <a:headEnd type="none" w="med" len="med"/>
+                      <a:tailEnd type="none" w="med" len="med"/>
+                    </a:lnL>
+                    <a:lnR w="6350" cap="flat" cmpd="sng" algn="ctr">
+                      <a:solidFill>
+                        <a:schemeClr val="tx1">
+                          <a:lumMod val="95000"/>
+                          <a:lumOff val="5000"/>
+                        </a:schemeClr>
+                      </a:solidFill>
+                      <a:prstDash val="solid"/>
+                      <a:round/>
+                      <a:headEnd type="none" w="med" len="med"/>
+                      <a:tailEnd type="none" w="med" len="med"/>
+                    </a:lnR>
+                    <a:lnT w="3175" cap="flat" cmpd="sng" algn="ctr">
+                      <a:solidFill>
+                        <a:schemeClr val="bg1">
+                          <a:lumMod val="65000"/>
+                        </a:schemeClr>
+                      </a:solidFill>
+                      <a:prstDash val="solid"/>
+                      <a:round/>
+                      <a:headEnd type="none" w="med" len="med"/>
+                      <a:tailEnd type="none" w="med" len="med"/>
+                    </a:lnT>
+                    <a:lnB w="3175" cap="flat" cmpd="sng" algn="ctr">
+                      <a:solidFill>
+                        <a:schemeClr val="bg1">
+                          <a:lumMod val="65000"/>
+                        </a:schemeClr>
+                      </a:solidFill>
+                      <a:prstDash val="solid"/>
+                      <a:round/>
+                      <a:headEnd type="none" w="med" len="med"/>
+                      <a:tailEnd type="none" w="med" len="med"/>
+                    </a:lnB>
+                  </a:tcPr>
+                </a:tc>
+                <a:extLst>
+                  <a:ext uri="{0D108BD9-81ED-4DB2-BD59-A6C34878D82A}">
+                    <a16:rowId xmlns:a16="http://schemas.microsoft.com/office/drawing/2014/main" val="1729711567"/>
+                  </a:ext>
+                </a:extLst>
+              </a:tr>
+              <a:tr h="106163">
+                <a:tc>
+                  <a:txBody>
+                    <a:bodyPr/>
+                    <a:lstStyle/>
+                    <a:p>
+                      <a:pPr algn="ctr" fontAlgn="b">
+                        <a:buNone/>
+                      </a:pPr>
+                      <a:r>
+                        <a:rPr lang="en-CA" sz="1200" b="0" i="0" u="none" strike="noStrike" dirty="0">
+                          <a:solidFill>
+                            <a:srgbClr val="000000"/>
+                          </a:solidFill>
+                          <a:effectLst/>
+                          <a:latin typeface="Courier New" panose="02070309020205020404" pitchFamily="49" charset="0"/>
+                          <a:cs typeface="Courier New" panose="02070309020205020404" pitchFamily="49" charset="0"/>
+                        </a:rPr>
+                        <a:t>32937646</a:t>
+                      </a:r>
+                    </a:p>
+                  </a:txBody>
+                  <a:tcPr marL="6350" marR="6350" marT="6350" marB="0" anchor="b">
+                    <a:lnL w="6350" cap="flat" cmpd="sng" algn="ctr">
+                      <a:solidFill>
+                        <a:schemeClr val="tx1">
+                          <a:lumMod val="95000"/>
+                          <a:lumOff val="5000"/>
+                        </a:schemeClr>
+                      </a:solidFill>
+                      <a:prstDash val="solid"/>
+                      <a:round/>
+                      <a:headEnd type="none" w="med" len="med"/>
+                      <a:tailEnd type="none" w="med" len="med"/>
+                    </a:lnL>
+                    <a:lnR w="3175" cap="flat" cmpd="sng" algn="ctr">
+                      <a:solidFill>
+                        <a:schemeClr val="bg1">
+                          <a:lumMod val="65000"/>
+                        </a:schemeClr>
+                      </a:solidFill>
+                      <a:prstDash val="solid"/>
+                      <a:round/>
+                      <a:headEnd type="none" w="med" len="med"/>
+                      <a:tailEnd type="none" w="med" len="med"/>
+                    </a:lnR>
+                    <a:lnT w="3175" cap="flat" cmpd="sng" algn="ctr">
+                      <a:solidFill>
+                        <a:schemeClr val="bg1">
+                          <a:lumMod val="65000"/>
+                        </a:schemeClr>
+                      </a:solidFill>
+                      <a:prstDash val="solid"/>
+                      <a:round/>
+                      <a:headEnd type="none" w="med" len="med"/>
+                      <a:tailEnd type="none" w="med" len="med"/>
+                    </a:lnT>
+                    <a:lnB w="3175" cap="flat" cmpd="sng" algn="ctr">
+                      <a:solidFill>
+                        <a:schemeClr val="bg1">
+                          <a:lumMod val="65000"/>
+                        </a:schemeClr>
+                      </a:solidFill>
+                      <a:prstDash val="solid"/>
+                      <a:round/>
+                      <a:headEnd type="none" w="med" len="med"/>
+                      <a:tailEnd type="none" w="med" len="med"/>
+                    </a:lnB>
+                  </a:tcPr>
+                </a:tc>
+                <a:tc>
+                  <a:txBody>
+                    <a:bodyPr/>
+                    <a:lstStyle/>
+                    <a:p>
+                      <a:pPr algn="ctr" fontAlgn="b">
+                        <a:buNone/>
+                      </a:pPr>
+                      <a:r>
+                        <a:rPr lang="en-CA" sz="1200" b="0" i="0" u="none" strike="noStrike" dirty="0">
+                          <a:solidFill>
+                            <a:srgbClr val="000000"/>
+                          </a:solidFill>
+                          <a:effectLst/>
+                          <a:latin typeface="Courier New" panose="02070309020205020404" pitchFamily="49" charset="0"/>
+                          <a:cs typeface="Courier New" panose="02070309020205020404" pitchFamily="49" charset="0"/>
+                        </a:rPr>
+                        <a:t>vip6</a:t>
+                      </a:r>
+                    </a:p>
+                  </a:txBody>
+                  <a:tcPr marL="6350" marR="6350" marT="6350" marB="0" anchor="b">
+                    <a:lnL w="3175" cap="flat" cmpd="sng" algn="ctr">
+                      <a:solidFill>
+                        <a:schemeClr val="bg1">
+                          <a:lumMod val="65000"/>
+                        </a:schemeClr>
+                      </a:solidFill>
+                      <a:prstDash val="solid"/>
+                      <a:round/>
+                      <a:headEnd type="none" w="med" len="med"/>
+                      <a:tailEnd type="none" w="med" len="med"/>
+                    </a:lnL>
+                    <a:lnR w="3175" cap="flat" cmpd="sng" algn="ctr">
+                      <a:solidFill>
+                        <a:schemeClr val="bg1">
+                          <a:lumMod val="65000"/>
+                        </a:schemeClr>
+                      </a:solidFill>
+                      <a:prstDash val="solid"/>
+                      <a:round/>
+                      <a:headEnd type="none" w="med" len="med"/>
+                      <a:tailEnd type="none" w="med" len="med"/>
+                    </a:lnR>
+                    <a:lnT w="3175" cap="flat" cmpd="sng" algn="ctr">
+                      <a:solidFill>
+                        <a:schemeClr val="bg1">
+                          <a:lumMod val="65000"/>
+                        </a:schemeClr>
+                      </a:solidFill>
+                      <a:prstDash val="solid"/>
+                      <a:round/>
+                      <a:headEnd type="none" w="med" len="med"/>
+                      <a:tailEnd type="none" w="med" len="med"/>
+                    </a:lnT>
+                    <a:lnB w="3175" cap="flat" cmpd="sng" algn="ctr">
+                      <a:solidFill>
+                        <a:schemeClr val="bg1">
+                          <a:lumMod val="65000"/>
+                        </a:schemeClr>
+                      </a:solidFill>
+                      <a:prstDash val="solid"/>
+                      <a:round/>
+                      <a:headEnd type="none" w="med" len="med"/>
+                      <a:tailEnd type="none" w="med" len="med"/>
+                    </a:lnB>
+                  </a:tcPr>
+                </a:tc>
+                <a:tc>
+                  <a:txBody>
+                    <a:bodyPr/>
+                    <a:lstStyle/>
+                    <a:p>
+                      <a:pPr algn="ctr" fontAlgn="b">
+                        <a:buNone/>
+                      </a:pPr>
+                      <a:r>
+                        <a:rPr lang="en-CA" sz="1200" b="0" i="0" u="none" strike="noStrike" dirty="0">
+                          <a:solidFill>
+                            <a:srgbClr val="000000"/>
+                          </a:solidFill>
+                          <a:effectLst/>
+                          <a:latin typeface="Courier New" panose="02070309020205020404" pitchFamily="49" charset="0"/>
+                          <a:cs typeface="Courier New" panose="02070309020205020404" pitchFamily="49" charset="0"/>
+                        </a:rPr>
+                        <a:t>RSAD2</a:t>
+                      </a:r>
+                    </a:p>
+                  </a:txBody>
+                  <a:tcPr marL="6350" marR="6350" marT="6350" marB="0" anchor="b">
+                    <a:lnL w="3175" cap="flat" cmpd="sng" algn="ctr">
+                      <a:solidFill>
+                        <a:schemeClr val="bg1">
+                          <a:lumMod val="65000"/>
+                        </a:schemeClr>
+                      </a:solidFill>
+                      <a:prstDash val="solid"/>
+                      <a:round/>
+                      <a:headEnd type="none" w="med" len="med"/>
+                      <a:tailEnd type="none" w="med" len="med"/>
+                    </a:lnL>
+                    <a:lnR w="6350" cap="flat" cmpd="sng" algn="ctr">
+                      <a:solidFill>
+                        <a:schemeClr val="tx1">
+                          <a:lumMod val="95000"/>
+                          <a:lumOff val="5000"/>
+                        </a:schemeClr>
+                      </a:solidFill>
+                      <a:prstDash val="solid"/>
+                      <a:round/>
+                      <a:headEnd type="none" w="med" len="med"/>
+                      <a:tailEnd type="none" w="med" len="med"/>
+                    </a:lnR>
+                    <a:lnT w="3175" cap="flat" cmpd="sng" algn="ctr">
+                      <a:solidFill>
+                        <a:schemeClr val="bg1">
+                          <a:lumMod val="65000"/>
+                        </a:schemeClr>
+                      </a:solidFill>
+                      <a:prstDash val="solid"/>
+                      <a:round/>
+                      <a:headEnd type="none" w="med" len="med"/>
+                      <a:tailEnd type="none" w="med" len="med"/>
+                    </a:lnT>
+                    <a:lnB w="3175" cap="flat" cmpd="sng" algn="ctr">
+                      <a:solidFill>
+                        <a:schemeClr val="bg1">
+                          <a:lumMod val="65000"/>
+                        </a:schemeClr>
+                      </a:solidFill>
+                      <a:prstDash val="solid"/>
+                      <a:round/>
+                      <a:headEnd type="none" w="med" len="med"/>
+                      <a:tailEnd type="none" w="med" len="med"/>
+                    </a:lnB>
+                  </a:tcPr>
+                </a:tc>
+                <a:extLst>
+                  <a:ext uri="{0D108BD9-81ED-4DB2-BD59-A6C34878D82A}">
+                    <a16:rowId xmlns:a16="http://schemas.microsoft.com/office/drawing/2014/main" val="159225769"/>
+                  </a:ext>
+                </a:extLst>
+              </a:tr>
+              <a:tr h="106163">
+                <a:tc>
+                  <a:txBody>
+                    <a:bodyPr/>
+                    <a:lstStyle/>
+                    <a:p>
+                      <a:pPr algn="ctr" fontAlgn="b">
+                        <a:buNone/>
+                      </a:pPr>
+                      <a:r>
+                        <a:rPr lang="en-CA" sz="1200" b="0" i="0" u="none" strike="noStrike" dirty="0">
+                          <a:solidFill>
+                            <a:srgbClr val="000000"/>
+                          </a:solidFill>
+                          <a:effectLst/>
+                          <a:latin typeface="Courier New" panose="02070309020205020404" pitchFamily="49" charset="0"/>
+                          <a:cs typeface="Courier New" panose="02070309020205020404" pitchFamily="49" charset="0"/>
+                        </a:rPr>
+                        <a:t>32937646</a:t>
+                      </a:r>
+                    </a:p>
+                  </a:txBody>
+                  <a:tcPr marL="6350" marR="6350" marT="6350" marB="0" anchor="b">
+                    <a:lnL w="6350" cap="flat" cmpd="sng" algn="ctr">
+                      <a:solidFill>
+                        <a:schemeClr val="tx1">
+                          <a:lumMod val="95000"/>
+                          <a:lumOff val="5000"/>
+                        </a:schemeClr>
+                      </a:solidFill>
+                      <a:prstDash val="solid"/>
+                      <a:round/>
+                      <a:headEnd type="none" w="med" len="med"/>
+                      <a:tailEnd type="none" w="med" len="med"/>
+                    </a:lnL>
+                    <a:lnR w="3175" cap="flat" cmpd="sng" algn="ctr">
+                      <a:solidFill>
+                        <a:schemeClr val="bg1">
+                          <a:lumMod val="65000"/>
+                        </a:schemeClr>
+                      </a:solidFill>
+                      <a:prstDash val="solid"/>
+                      <a:round/>
+                      <a:headEnd type="none" w="med" len="med"/>
+                      <a:tailEnd type="none" w="med" len="med"/>
+                    </a:lnR>
+                    <a:lnT w="3175" cap="flat" cmpd="sng" algn="ctr">
+                      <a:solidFill>
+                        <a:schemeClr val="bg1">
+                          <a:lumMod val="65000"/>
+                        </a:schemeClr>
+                      </a:solidFill>
+                      <a:prstDash val="solid"/>
+                      <a:round/>
+                      <a:headEnd type="none" w="med" len="med"/>
+                      <a:tailEnd type="none" w="med" len="med"/>
+                    </a:lnT>
+                    <a:lnB w="3175" cap="flat" cmpd="sng" algn="ctr">
+                      <a:solidFill>
+                        <a:schemeClr val="bg1">
+                          <a:lumMod val="65000"/>
+                        </a:schemeClr>
+                      </a:solidFill>
+                      <a:prstDash val="solid"/>
+                      <a:round/>
+                      <a:headEnd type="none" w="med" len="med"/>
+                      <a:tailEnd type="none" w="med" len="med"/>
+                    </a:lnB>
+                  </a:tcPr>
+                </a:tc>
+                <a:tc>
+                  <a:txBody>
+                    <a:bodyPr/>
+                    <a:lstStyle/>
+                    <a:p>
+                      <a:pPr algn="ctr" fontAlgn="b">
+                        <a:buNone/>
+                      </a:pPr>
+                      <a:r>
+                        <a:rPr lang="en-CA" sz="1200" b="0" i="0" u="none" strike="noStrike" dirty="0">
+                          <a:solidFill>
+                            <a:srgbClr val="000000"/>
+                          </a:solidFill>
+                          <a:effectLst/>
+                          <a:latin typeface="Courier New" panose="02070309020205020404" pitchFamily="49" charset="0"/>
+                          <a:cs typeface="Courier New" panose="02070309020205020404" pitchFamily="49" charset="0"/>
+                        </a:rPr>
+                        <a:t>vip8</a:t>
+                      </a:r>
+                    </a:p>
+                  </a:txBody>
+                  <a:tcPr marL="6350" marR="6350" marT="6350" marB="0" anchor="b">
+                    <a:lnL w="3175" cap="flat" cmpd="sng" algn="ctr">
+                      <a:solidFill>
+                        <a:schemeClr val="bg1">
+                          <a:lumMod val="65000"/>
+                        </a:schemeClr>
+                      </a:solidFill>
+                      <a:prstDash val="solid"/>
+                      <a:round/>
+                      <a:headEnd type="none" w="med" len="med"/>
+                      <a:tailEnd type="none" w="med" len="med"/>
+                    </a:lnL>
+                    <a:lnR w="3175" cap="flat" cmpd="sng" algn="ctr">
+                      <a:solidFill>
+                        <a:schemeClr val="bg1">
+                          <a:lumMod val="65000"/>
+                        </a:schemeClr>
+                      </a:solidFill>
+                      <a:prstDash val="solid"/>
+                      <a:round/>
+                      <a:headEnd type="none" w="med" len="med"/>
+                      <a:tailEnd type="none" w="med" len="med"/>
+                    </a:lnR>
+                    <a:lnT w="3175" cap="flat" cmpd="sng" algn="ctr">
+                      <a:solidFill>
+                        <a:schemeClr val="bg1">
+                          <a:lumMod val="65000"/>
+                        </a:schemeClr>
+                      </a:solidFill>
+                      <a:prstDash val="solid"/>
+                      <a:round/>
+                      <a:headEnd type="none" w="med" len="med"/>
+                      <a:tailEnd type="none" w="med" len="med"/>
+                    </a:lnT>
+                    <a:lnB w="3175" cap="flat" cmpd="sng" algn="ctr">
+                      <a:solidFill>
+                        <a:schemeClr val="bg1">
+                          <a:lumMod val="65000"/>
+                        </a:schemeClr>
+                      </a:solidFill>
+                      <a:prstDash val="solid"/>
+                      <a:round/>
+                      <a:headEnd type="none" w="med" len="med"/>
+                      <a:tailEnd type="none" w="med" len="med"/>
+                    </a:lnB>
+                  </a:tcPr>
+                </a:tc>
+                <a:tc>
+                  <a:txBody>
+                    <a:bodyPr/>
+                    <a:lstStyle/>
+                    <a:p>
+                      <a:pPr algn="ctr" fontAlgn="b">
+                        <a:buNone/>
+                      </a:pPr>
+                      <a:r>
+                        <a:rPr lang="en-CA" sz="1200" b="0" i="0" u="none" strike="noStrike" dirty="0">
+                          <a:solidFill>
+                            <a:srgbClr val="000000"/>
+                          </a:solidFill>
+                          <a:effectLst/>
+                          <a:latin typeface="Courier New" panose="02070309020205020404" pitchFamily="49" charset="0"/>
+                          <a:cs typeface="Courier New" panose="02070309020205020404" pitchFamily="49" charset="0"/>
+                        </a:rPr>
+                        <a:t>RSAD2</a:t>
+                      </a:r>
+                    </a:p>
+                  </a:txBody>
+                  <a:tcPr marL="6350" marR="6350" marT="6350" marB="0" anchor="b">
+                    <a:lnL w="3175" cap="flat" cmpd="sng" algn="ctr">
+                      <a:solidFill>
+                        <a:schemeClr val="bg1">
+                          <a:lumMod val="65000"/>
+                        </a:schemeClr>
+                      </a:solidFill>
+                      <a:prstDash val="solid"/>
+                      <a:round/>
+                      <a:headEnd type="none" w="med" len="med"/>
+                      <a:tailEnd type="none" w="med" len="med"/>
+                    </a:lnL>
+                    <a:lnR w="6350" cap="flat" cmpd="sng" algn="ctr">
+                      <a:solidFill>
+                        <a:schemeClr val="tx1">
+                          <a:lumMod val="95000"/>
+                          <a:lumOff val="5000"/>
+                        </a:schemeClr>
+                      </a:solidFill>
+                      <a:prstDash val="solid"/>
+                      <a:round/>
+                      <a:headEnd type="none" w="med" len="med"/>
+                      <a:tailEnd type="none" w="med" len="med"/>
+                    </a:lnR>
+                    <a:lnT w="3175" cap="flat" cmpd="sng" algn="ctr">
+                      <a:solidFill>
+                        <a:schemeClr val="bg1">
+                          <a:lumMod val="65000"/>
+                        </a:schemeClr>
+                      </a:solidFill>
+                      <a:prstDash val="solid"/>
+                      <a:round/>
+                      <a:headEnd type="none" w="med" len="med"/>
+                      <a:tailEnd type="none" w="med" len="med"/>
+                    </a:lnT>
+                    <a:lnB w="3175" cap="flat" cmpd="sng" algn="ctr">
+                      <a:solidFill>
+                        <a:schemeClr val="bg1">
+                          <a:lumMod val="65000"/>
+                        </a:schemeClr>
+                      </a:solidFill>
+                      <a:prstDash val="solid"/>
+                      <a:round/>
+                      <a:headEnd type="none" w="med" len="med"/>
+                      <a:tailEnd type="none" w="med" len="med"/>
+                    </a:lnB>
+                  </a:tcPr>
+                </a:tc>
+                <a:extLst>
+                  <a:ext uri="{0D108BD9-81ED-4DB2-BD59-A6C34878D82A}">
+                    <a16:rowId xmlns:a16="http://schemas.microsoft.com/office/drawing/2014/main" val="2306671522"/>
+                  </a:ext>
+                </a:extLst>
+              </a:tr>
+              <a:tr h="106163">
+                <a:tc>
+                  <a:txBody>
+                    <a:bodyPr/>
+                    <a:lstStyle/>
+                    <a:p>
+                      <a:pPr algn="ctr" fontAlgn="b">
+                        <a:buNone/>
+                      </a:pPr>
+                      <a:r>
+                        <a:rPr lang="en-CA" sz="1200" b="0" i="0" u="none" strike="noStrike" dirty="0">
+                          <a:solidFill>
+                            <a:srgbClr val="000000"/>
+                          </a:solidFill>
+                          <a:effectLst/>
+                          <a:latin typeface="Courier New" panose="02070309020205020404" pitchFamily="49" charset="0"/>
+                          <a:cs typeface="Courier New" panose="02070309020205020404" pitchFamily="49" charset="0"/>
+                        </a:rPr>
+                        <a:t>32937646</a:t>
+                      </a:r>
+                    </a:p>
+                  </a:txBody>
+                  <a:tcPr marL="6350" marR="6350" marT="6350" marB="0" anchor="b">
+                    <a:lnL w="6350" cap="flat" cmpd="sng" algn="ctr">
+                      <a:solidFill>
+                        <a:schemeClr val="tx1">
+                          <a:lumMod val="95000"/>
+                          <a:lumOff val="5000"/>
+                        </a:schemeClr>
+                      </a:solidFill>
+                      <a:prstDash val="solid"/>
+                      <a:round/>
+                      <a:headEnd type="none" w="med" len="med"/>
+                      <a:tailEnd type="none" w="med" len="med"/>
+                    </a:lnL>
+                    <a:lnR w="3175" cap="flat" cmpd="sng" algn="ctr">
+                      <a:solidFill>
+                        <a:schemeClr val="bg1">
+                          <a:lumMod val="65000"/>
+                        </a:schemeClr>
+                      </a:solidFill>
+                      <a:prstDash val="solid"/>
+                      <a:round/>
+                      <a:headEnd type="none" w="med" len="med"/>
+                      <a:tailEnd type="none" w="med" len="med"/>
+                    </a:lnR>
+                    <a:lnT w="3175" cap="flat" cmpd="sng" algn="ctr">
+                      <a:solidFill>
+                        <a:schemeClr val="bg1">
+                          <a:lumMod val="65000"/>
+                        </a:schemeClr>
+                      </a:solidFill>
+                      <a:prstDash val="solid"/>
+                      <a:round/>
+                      <a:headEnd type="none" w="med" len="med"/>
+                      <a:tailEnd type="none" w="med" len="med"/>
+                    </a:lnT>
+                    <a:lnB w="3175" cap="flat" cmpd="sng" algn="ctr">
+                      <a:solidFill>
+                        <a:schemeClr val="bg1">
+                          <a:lumMod val="65000"/>
+                        </a:schemeClr>
+                      </a:solidFill>
+                      <a:prstDash val="solid"/>
+                      <a:round/>
+                      <a:headEnd type="none" w="med" len="med"/>
+                      <a:tailEnd type="none" w="med" len="med"/>
+                    </a:lnB>
+                  </a:tcPr>
+                </a:tc>
+                <a:tc>
+                  <a:txBody>
+                    <a:bodyPr/>
+                    <a:lstStyle/>
+                    <a:p>
+                      <a:pPr algn="ctr" fontAlgn="b">
+                        <a:buNone/>
+                      </a:pPr>
+                      <a:r>
+                        <a:rPr lang="en-CA" sz="1200" b="0" i="0" u="none" strike="noStrike" dirty="0">
+                          <a:solidFill>
+                            <a:srgbClr val="000000"/>
+                          </a:solidFill>
+                          <a:effectLst/>
+                          <a:latin typeface="Courier New" panose="02070309020205020404" pitchFamily="49" charset="0"/>
+                          <a:cs typeface="Courier New" panose="02070309020205020404" pitchFamily="49" charset="0"/>
+                        </a:rPr>
+                        <a:t>vip15</a:t>
+                      </a:r>
+                    </a:p>
+                  </a:txBody>
+                  <a:tcPr marL="6350" marR="6350" marT="6350" marB="0" anchor="b">
+                    <a:lnL w="3175" cap="flat" cmpd="sng" algn="ctr">
+                      <a:solidFill>
+                        <a:schemeClr val="bg1">
+                          <a:lumMod val="65000"/>
+                        </a:schemeClr>
+                      </a:solidFill>
+                      <a:prstDash val="solid"/>
+                      <a:round/>
+                      <a:headEnd type="none" w="med" len="med"/>
+                      <a:tailEnd type="none" w="med" len="med"/>
+                    </a:lnL>
+                    <a:lnR w="3175" cap="flat" cmpd="sng" algn="ctr">
+                      <a:solidFill>
+                        <a:schemeClr val="bg1">
+                          <a:lumMod val="65000"/>
+                        </a:schemeClr>
+                      </a:solidFill>
+                      <a:prstDash val="solid"/>
+                      <a:round/>
+                      <a:headEnd type="none" w="med" len="med"/>
+                      <a:tailEnd type="none" w="med" len="med"/>
+                    </a:lnR>
+                    <a:lnT w="3175" cap="flat" cmpd="sng" algn="ctr">
+                      <a:solidFill>
+                        <a:schemeClr val="bg1">
+                          <a:lumMod val="65000"/>
+                        </a:schemeClr>
+                      </a:solidFill>
+                      <a:prstDash val="solid"/>
+                      <a:round/>
+                      <a:headEnd type="none" w="med" len="med"/>
+                      <a:tailEnd type="none" w="med" len="med"/>
+                    </a:lnT>
+                    <a:lnB w="3175" cap="flat" cmpd="sng" algn="ctr">
+                      <a:solidFill>
+                        <a:schemeClr val="bg1">
+                          <a:lumMod val="65000"/>
+                        </a:schemeClr>
+                      </a:solidFill>
+                      <a:prstDash val="solid"/>
+                      <a:round/>
+                      <a:headEnd type="none" w="med" len="med"/>
+                      <a:tailEnd type="none" w="med" len="med"/>
+                    </a:lnB>
+                  </a:tcPr>
+                </a:tc>
+                <a:tc>
+                  <a:txBody>
+                    <a:bodyPr/>
+                    <a:lstStyle/>
+                    <a:p>
+                      <a:pPr algn="ctr" fontAlgn="b">
+                        <a:buNone/>
+                      </a:pPr>
+                      <a:r>
+                        <a:rPr lang="en-CA" sz="1200" b="0" i="0" u="none" strike="noStrike" dirty="0">
+                          <a:solidFill>
+                            <a:srgbClr val="000000"/>
+                          </a:solidFill>
+                          <a:effectLst/>
+                          <a:latin typeface="Courier New" panose="02070309020205020404" pitchFamily="49" charset="0"/>
+                          <a:cs typeface="Courier New" panose="02070309020205020404" pitchFamily="49" charset="0"/>
+                        </a:rPr>
+                        <a:t>RSAD2</a:t>
+                      </a:r>
+                    </a:p>
+                  </a:txBody>
+                  <a:tcPr marL="6350" marR="6350" marT="6350" marB="0" anchor="b">
+                    <a:lnL w="3175" cap="flat" cmpd="sng" algn="ctr">
+                      <a:solidFill>
+                        <a:schemeClr val="bg1">
+                          <a:lumMod val="65000"/>
+                        </a:schemeClr>
+                      </a:solidFill>
+                      <a:prstDash val="solid"/>
+                      <a:round/>
+                      <a:headEnd type="none" w="med" len="med"/>
+                      <a:tailEnd type="none" w="med" len="med"/>
+                    </a:lnL>
+                    <a:lnR w="6350" cap="flat" cmpd="sng" algn="ctr">
+                      <a:solidFill>
+                        <a:schemeClr val="tx1">
+                          <a:lumMod val="95000"/>
+                          <a:lumOff val="5000"/>
+                        </a:schemeClr>
+                      </a:solidFill>
+                      <a:prstDash val="solid"/>
+                      <a:round/>
+                      <a:headEnd type="none" w="med" len="med"/>
+                      <a:tailEnd type="none" w="med" len="med"/>
+                    </a:lnR>
+                    <a:lnT w="3175" cap="flat" cmpd="sng" algn="ctr">
+                      <a:solidFill>
+                        <a:schemeClr val="bg1">
+                          <a:lumMod val="65000"/>
+                        </a:schemeClr>
+                      </a:solidFill>
+                      <a:prstDash val="solid"/>
+                      <a:round/>
+                      <a:headEnd type="none" w="med" len="med"/>
+                      <a:tailEnd type="none" w="med" len="med"/>
+                    </a:lnT>
+                    <a:lnB w="3175" cap="flat" cmpd="sng" algn="ctr">
+                      <a:solidFill>
+                        <a:schemeClr val="bg1">
+                          <a:lumMod val="65000"/>
+                        </a:schemeClr>
+                      </a:solidFill>
+                      <a:prstDash val="solid"/>
+                      <a:round/>
+                      <a:headEnd type="none" w="med" len="med"/>
+                      <a:tailEnd type="none" w="med" len="med"/>
+                    </a:lnB>
+                  </a:tcPr>
+                </a:tc>
+                <a:extLst>
+                  <a:ext uri="{0D108BD9-81ED-4DB2-BD59-A6C34878D82A}">
+                    <a16:rowId xmlns:a16="http://schemas.microsoft.com/office/drawing/2014/main" val="2571060587"/>
+                  </a:ext>
+                </a:extLst>
+              </a:tr>
+              <a:tr h="106163">
+                <a:tc>
+                  <a:txBody>
+                    <a:bodyPr/>
+                    <a:lstStyle/>
+                    <a:p>
+                      <a:pPr algn="ctr" fontAlgn="b">
+                        <a:buNone/>
+                      </a:pPr>
+                      <a:r>
+                        <a:rPr lang="en-CA" sz="1200" b="0" i="0" u="none" strike="noStrike" dirty="0">
+                          <a:solidFill>
+                            <a:srgbClr val="000000"/>
+                          </a:solidFill>
+                          <a:effectLst/>
+                          <a:latin typeface="Courier New" panose="02070309020205020404" pitchFamily="49" charset="0"/>
+                          <a:cs typeface="Courier New" panose="02070309020205020404" pitchFamily="49" charset="0"/>
+                        </a:rPr>
+                        <a:t>32937646</a:t>
+                      </a:r>
+                    </a:p>
+                  </a:txBody>
+                  <a:tcPr marL="6350" marR="6350" marT="6350" marB="0" anchor="b">
+                    <a:lnL w="6350" cap="flat" cmpd="sng" algn="ctr">
+                      <a:solidFill>
+                        <a:schemeClr val="tx1">
+                          <a:lumMod val="95000"/>
+                          <a:lumOff val="5000"/>
+                        </a:schemeClr>
+                      </a:solidFill>
+                      <a:prstDash val="solid"/>
+                      <a:round/>
+                      <a:headEnd type="none" w="med" len="med"/>
+                      <a:tailEnd type="none" w="med" len="med"/>
+                    </a:lnL>
+                    <a:lnR w="3175" cap="flat" cmpd="sng" algn="ctr">
+                      <a:solidFill>
+                        <a:schemeClr val="bg1">
+                          <a:lumMod val="65000"/>
+                        </a:schemeClr>
+                      </a:solidFill>
+                      <a:prstDash val="solid"/>
+                      <a:round/>
+                      <a:headEnd type="none" w="med" len="med"/>
+                      <a:tailEnd type="none" w="med" len="med"/>
+                    </a:lnR>
+                    <a:lnT w="3175" cap="flat" cmpd="sng" algn="ctr">
+                      <a:solidFill>
+                        <a:schemeClr val="bg1">
+                          <a:lumMod val="65000"/>
+                        </a:schemeClr>
+                      </a:solidFill>
+                      <a:prstDash val="solid"/>
+                      <a:round/>
+                      <a:headEnd type="none" w="med" len="med"/>
+                      <a:tailEnd type="none" w="med" len="med"/>
+                    </a:lnT>
+                    <a:lnB w="3175" cap="flat" cmpd="sng" algn="ctr">
+                      <a:solidFill>
+                        <a:schemeClr val="bg1">
+                          <a:lumMod val="65000"/>
+                        </a:schemeClr>
+                      </a:solidFill>
+                      <a:prstDash val="solid"/>
+                      <a:round/>
+                      <a:headEnd type="none" w="med" len="med"/>
+                      <a:tailEnd type="none" w="med" len="med"/>
+                    </a:lnB>
+                  </a:tcPr>
+                </a:tc>
+                <a:tc>
+                  <a:txBody>
+                    <a:bodyPr/>
+                    <a:lstStyle/>
+                    <a:p>
+                      <a:pPr algn="ctr" fontAlgn="b">
+                        <a:buNone/>
+                      </a:pPr>
+                      <a:r>
+                        <a:rPr lang="en-CA" sz="1200" b="0" i="0" u="none" strike="noStrike" dirty="0">
+                          <a:solidFill>
+                            <a:srgbClr val="000000"/>
+                          </a:solidFill>
+                          <a:effectLst/>
+                          <a:latin typeface="Courier New" panose="02070309020205020404" pitchFamily="49" charset="0"/>
+                          <a:cs typeface="Courier New" panose="02070309020205020404" pitchFamily="49" charset="0"/>
+                        </a:rPr>
+                        <a:t>vip21</a:t>
+                      </a:r>
+                    </a:p>
+                  </a:txBody>
+                  <a:tcPr marL="6350" marR="6350" marT="6350" marB="0" anchor="b">
+                    <a:lnL w="3175" cap="flat" cmpd="sng" algn="ctr">
+                      <a:solidFill>
+                        <a:schemeClr val="bg1">
+                          <a:lumMod val="65000"/>
+                        </a:schemeClr>
+                      </a:solidFill>
+                      <a:prstDash val="solid"/>
+                      <a:round/>
+                      <a:headEnd type="none" w="med" len="med"/>
+                      <a:tailEnd type="none" w="med" len="med"/>
+                    </a:lnL>
+                    <a:lnR w="3175" cap="flat" cmpd="sng" algn="ctr">
+                      <a:solidFill>
+                        <a:schemeClr val="bg1">
+                          <a:lumMod val="65000"/>
+                        </a:schemeClr>
+                      </a:solidFill>
+                      <a:prstDash val="solid"/>
+                      <a:round/>
+                      <a:headEnd type="none" w="med" len="med"/>
+                      <a:tailEnd type="none" w="med" len="med"/>
+                    </a:lnR>
+                    <a:lnT w="3175" cap="flat" cmpd="sng" algn="ctr">
+                      <a:solidFill>
+                        <a:schemeClr val="bg1">
+                          <a:lumMod val="65000"/>
+                        </a:schemeClr>
+                      </a:solidFill>
+                      <a:prstDash val="solid"/>
+                      <a:round/>
+                      <a:headEnd type="none" w="med" len="med"/>
+                      <a:tailEnd type="none" w="med" len="med"/>
+                    </a:lnT>
+                    <a:lnB w="3175" cap="flat" cmpd="sng" algn="ctr">
+                      <a:solidFill>
+                        <a:schemeClr val="bg1">
+                          <a:lumMod val="65000"/>
+                        </a:schemeClr>
+                      </a:solidFill>
+                      <a:prstDash val="solid"/>
+                      <a:round/>
+                      <a:headEnd type="none" w="med" len="med"/>
+                      <a:tailEnd type="none" w="med" len="med"/>
+                    </a:lnB>
+                  </a:tcPr>
+                </a:tc>
+                <a:tc>
+                  <a:txBody>
+                    <a:bodyPr/>
+                    <a:lstStyle/>
+                    <a:p>
+                      <a:pPr algn="ctr" fontAlgn="b">
+                        <a:buNone/>
+                      </a:pPr>
+                      <a:r>
+                        <a:rPr lang="en-CA" sz="1200" b="0" i="0" u="none" strike="noStrike" dirty="0">
+                          <a:solidFill>
+                            <a:srgbClr val="000000"/>
+                          </a:solidFill>
+                          <a:effectLst/>
+                          <a:latin typeface="Courier New" panose="02070309020205020404" pitchFamily="49" charset="0"/>
+                          <a:cs typeface="Courier New" panose="02070309020205020404" pitchFamily="49" charset="0"/>
+                        </a:rPr>
+                        <a:t>RSAD2</a:t>
+                      </a:r>
+                    </a:p>
+                  </a:txBody>
+                  <a:tcPr marL="6350" marR="6350" marT="6350" marB="0" anchor="b">
+                    <a:lnL w="3175" cap="flat" cmpd="sng" algn="ctr">
+                      <a:solidFill>
+                        <a:schemeClr val="bg1">
+                          <a:lumMod val="65000"/>
+                        </a:schemeClr>
+                      </a:solidFill>
+                      <a:prstDash val="solid"/>
+                      <a:round/>
+                      <a:headEnd type="none" w="med" len="med"/>
+                      <a:tailEnd type="none" w="med" len="med"/>
+                    </a:lnL>
+                    <a:lnR w="6350" cap="flat" cmpd="sng" algn="ctr">
+                      <a:solidFill>
+                        <a:schemeClr val="tx1">
+                          <a:lumMod val="95000"/>
+                          <a:lumOff val="5000"/>
+                        </a:schemeClr>
+                      </a:solidFill>
+                      <a:prstDash val="solid"/>
+                      <a:round/>
+                      <a:headEnd type="none" w="med" len="med"/>
+                      <a:tailEnd type="none" w="med" len="med"/>
+                    </a:lnR>
+                    <a:lnT w="3175" cap="flat" cmpd="sng" algn="ctr">
+                      <a:solidFill>
+                        <a:schemeClr val="bg1">
+                          <a:lumMod val="65000"/>
+                        </a:schemeClr>
+                      </a:solidFill>
+                      <a:prstDash val="solid"/>
+                      <a:round/>
+                      <a:headEnd type="none" w="med" len="med"/>
+                      <a:tailEnd type="none" w="med" len="med"/>
+                    </a:lnT>
+                    <a:lnB w="3175" cap="flat" cmpd="sng" algn="ctr">
+                      <a:solidFill>
+                        <a:schemeClr val="bg1">
+                          <a:lumMod val="65000"/>
+                        </a:schemeClr>
+                      </a:solidFill>
+                      <a:prstDash val="solid"/>
+                      <a:round/>
+                      <a:headEnd type="none" w="med" len="med"/>
+                      <a:tailEnd type="none" w="med" len="med"/>
+                    </a:lnB>
+                  </a:tcPr>
+                </a:tc>
+                <a:extLst>
+                  <a:ext uri="{0D108BD9-81ED-4DB2-BD59-A6C34878D82A}">
+                    <a16:rowId xmlns:a16="http://schemas.microsoft.com/office/drawing/2014/main" val="1681524863"/>
+                  </a:ext>
+                </a:extLst>
+              </a:tr>
+              <a:tr h="106163">
+                <a:tc>
+                  <a:txBody>
+                    <a:bodyPr/>
+                    <a:lstStyle/>
+                    <a:p>
+                      <a:pPr algn="ctr" fontAlgn="b">
+                        <a:buNone/>
+                      </a:pPr>
+                      <a:r>
+                        <a:rPr lang="en-CA" sz="1200" b="0" i="0" u="none" strike="noStrike" dirty="0">
+                          <a:solidFill>
+                            <a:srgbClr val="000000"/>
+                          </a:solidFill>
+                          <a:effectLst/>
+                          <a:latin typeface="Courier New" panose="02070309020205020404" pitchFamily="49" charset="0"/>
+                          <a:cs typeface="Courier New" panose="02070309020205020404" pitchFamily="49" charset="0"/>
+                        </a:rPr>
+                        <a:t>32937646</a:t>
+                      </a:r>
+                    </a:p>
+                  </a:txBody>
+                  <a:tcPr marL="6350" marR="6350" marT="6350" marB="0" anchor="b">
+                    <a:lnL w="6350" cap="flat" cmpd="sng" algn="ctr">
+                      <a:solidFill>
+                        <a:schemeClr val="tx1">
+                          <a:lumMod val="95000"/>
+                          <a:lumOff val="5000"/>
+                        </a:schemeClr>
+                      </a:solidFill>
+                      <a:prstDash val="solid"/>
+                      <a:round/>
+                      <a:headEnd type="none" w="med" len="med"/>
+                      <a:tailEnd type="none" w="med" len="med"/>
+                    </a:lnL>
+                    <a:lnR w="3175" cap="flat" cmpd="sng" algn="ctr">
+                      <a:solidFill>
+                        <a:schemeClr val="bg1">
+                          <a:lumMod val="65000"/>
+                        </a:schemeClr>
+                      </a:solidFill>
+                      <a:prstDash val="solid"/>
+                      <a:round/>
+                      <a:headEnd type="none" w="med" len="med"/>
+                      <a:tailEnd type="none" w="med" len="med"/>
+                    </a:lnR>
+                    <a:lnT w="3175" cap="flat" cmpd="sng" algn="ctr">
+                      <a:solidFill>
+                        <a:schemeClr val="bg1">
+                          <a:lumMod val="65000"/>
+                        </a:schemeClr>
+                      </a:solidFill>
+                      <a:prstDash val="solid"/>
+                      <a:round/>
+                      <a:headEnd type="none" w="med" len="med"/>
+                      <a:tailEnd type="none" w="med" len="med"/>
+                    </a:lnT>
+                    <a:lnB w="3175" cap="flat" cmpd="sng" algn="ctr">
+                      <a:solidFill>
+                        <a:schemeClr val="bg1">
+                          <a:lumMod val="65000"/>
+                        </a:schemeClr>
+                      </a:solidFill>
+                      <a:prstDash val="solid"/>
+                      <a:round/>
+                      <a:headEnd type="none" w="med" len="med"/>
+                      <a:tailEnd type="none" w="med" len="med"/>
+                    </a:lnB>
+                  </a:tcPr>
+                </a:tc>
+                <a:tc>
+                  <a:txBody>
+                    <a:bodyPr/>
+                    <a:lstStyle/>
+                    <a:p>
+                      <a:pPr algn="ctr" fontAlgn="b">
+                        <a:buNone/>
+                      </a:pPr>
+                      <a:r>
+                        <a:rPr lang="en-CA" sz="1200" b="0" i="0" u="none" strike="noStrike" dirty="0">
+                          <a:solidFill>
+                            <a:srgbClr val="000000"/>
+                          </a:solidFill>
+                          <a:effectLst/>
+                          <a:latin typeface="Courier New" panose="02070309020205020404" pitchFamily="49" charset="0"/>
+                          <a:cs typeface="Courier New" panose="02070309020205020404" pitchFamily="49" charset="0"/>
+                        </a:rPr>
+                        <a:t>vip47</a:t>
+                      </a:r>
+                    </a:p>
+                  </a:txBody>
+                  <a:tcPr marL="6350" marR="6350" marT="6350" marB="0" anchor="b">
+                    <a:lnL w="3175" cap="flat" cmpd="sng" algn="ctr">
+                      <a:solidFill>
+                        <a:schemeClr val="bg1">
+                          <a:lumMod val="65000"/>
+                        </a:schemeClr>
+                      </a:solidFill>
+                      <a:prstDash val="solid"/>
+                      <a:round/>
+                      <a:headEnd type="none" w="med" len="med"/>
+                      <a:tailEnd type="none" w="med" len="med"/>
+                    </a:lnL>
+                    <a:lnR w="3175" cap="flat" cmpd="sng" algn="ctr">
+                      <a:solidFill>
+                        <a:schemeClr val="bg1">
+                          <a:lumMod val="65000"/>
+                        </a:schemeClr>
+                      </a:solidFill>
+                      <a:prstDash val="solid"/>
+                      <a:round/>
+                      <a:headEnd type="none" w="med" len="med"/>
+                      <a:tailEnd type="none" w="med" len="med"/>
+                    </a:lnR>
+                    <a:lnT w="3175" cap="flat" cmpd="sng" algn="ctr">
+                      <a:solidFill>
+                        <a:schemeClr val="bg1">
+                          <a:lumMod val="65000"/>
+                        </a:schemeClr>
+                      </a:solidFill>
+                      <a:prstDash val="solid"/>
+                      <a:round/>
+                      <a:headEnd type="none" w="med" len="med"/>
+                      <a:tailEnd type="none" w="med" len="med"/>
+                    </a:lnT>
+                    <a:lnB w="3175" cap="flat" cmpd="sng" algn="ctr">
+                      <a:solidFill>
+                        <a:schemeClr val="bg1">
+                          <a:lumMod val="65000"/>
+                        </a:schemeClr>
+                      </a:solidFill>
+                      <a:prstDash val="solid"/>
+                      <a:round/>
+                      <a:headEnd type="none" w="med" len="med"/>
+                      <a:tailEnd type="none" w="med" len="med"/>
+                    </a:lnB>
+                  </a:tcPr>
+                </a:tc>
+                <a:tc>
+                  <a:txBody>
+                    <a:bodyPr/>
+                    <a:lstStyle/>
+                    <a:p>
+                      <a:pPr algn="ctr" fontAlgn="b">
+                        <a:buNone/>
+                      </a:pPr>
+                      <a:r>
+                        <a:rPr lang="en-CA" sz="1200" b="0" i="0" u="none" strike="noStrike" dirty="0">
+                          <a:solidFill>
+                            <a:srgbClr val="000000"/>
+                          </a:solidFill>
+                          <a:effectLst/>
+                          <a:latin typeface="Courier New" panose="02070309020205020404" pitchFamily="49" charset="0"/>
+                          <a:cs typeface="Courier New" panose="02070309020205020404" pitchFamily="49" charset="0"/>
+                        </a:rPr>
+                        <a:t>RSAD2</a:t>
+                      </a:r>
+                    </a:p>
+                  </a:txBody>
+                  <a:tcPr marL="6350" marR="6350" marT="6350" marB="0" anchor="b">
+                    <a:lnL w="3175" cap="flat" cmpd="sng" algn="ctr">
+                      <a:solidFill>
+                        <a:schemeClr val="bg1">
+                          <a:lumMod val="65000"/>
+                        </a:schemeClr>
+                      </a:solidFill>
+                      <a:prstDash val="solid"/>
+                      <a:round/>
+                      <a:headEnd type="none" w="med" len="med"/>
+                      <a:tailEnd type="none" w="med" len="med"/>
+                    </a:lnL>
+                    <a:lnR w="6350" cap="flat" cmpd="sng" algn="ctr">
+                      <a:solidFill>
+                        <a:schemeClr val="tx1">
+                          <a:lumMod val="95000"/>
+                          <a:lumOff val="5000"/>
+                        </a:schemeClr>
+                      </a:solidFill>
+                      <a:prstDash val="solid"/>
+                      <a:round/>
+                      <a:headEnd type="none" w="med" len="med"/>
+                      <a:tailEnd type="none" w="med" len="med"/>
+                    </a:lnR>
+                    <a:lnT w="3175" cap="flat" cmpd="sng" algn="ctr">
+                      <a:solidFill>
+                        <a:schemeClr val="bg1">
+                          <a:lumMod val="65000"/>
+                        </a:schemeClr>
+                      </a:solidFill>
+                      <a:prstDash val="solid"/>
+                      <a:round/>
+                      <a:headEnd type="none" w="med" len="med"/>
+                      <a:tailEnd type="none" w="med" len="med"/>
+                    </a:lnT>
+                    <a:lnB w="3175" cap="flat" cmpd="sng" algn="ctr">
+                      <a:solidFill>
+                        <a:schemeClr val="bg1">
+                          <a:lumMod val="65000"/>
+                        </a:schemeClr>
+                      </a:solidFill>
+                      <a:prstDash val="solid"/>
+                      <a:round/>
+                      <a:headEnd type="none" w="med" len="med"/>
+                      <a:tailEnd type="none" w="med" len="med"/>
+                    </a:lnB>
+                  </a:tcPr>
+                </a:tc>
+                <a:extLst>
+                  <a:ext uri="{0D108BD9-81ED-4DB2-BD59-A6C34878D82A}">
+                    <a16:rowId xmlns:a16="http://schemas.microsoft.com/office/drawing/2014/main" val="2450247763"/>
+                  </a:ext>
+                </a:extLst>
+              </a:tr>
+              <a:tr h="106163">
+                <a:tc>
+                  <a:txBody>
+                    <a:bodyPr/>
+                    <a:lstStyle/>
+                    <a:p>
+                      <a:pPr algn="ctr" fontAlgn="b">
+                        <a:buNone/>
+                      </a:pPr>
+                      <a:r>
+                        <a:rPr lang="en-CA" sz="1200" b="0" i="0" u="none" strike="noStrike" dirty="0">
+                          <a:solidFill>
+                            <a:srgbClr val="000000"/>
+                          </a:solidFill>
+                          <a:effectLst/>
+                          <a:latin typeface="Courier New" panose="02070309020205020404" pitchFamily="49" charset="0"/>
+                          <a:cs typeface="Courier New" panose="02070309020205020404" pitchFamily="49" charset="0"/>
+                        </a:rPr>
+                        <a:t>32937646</a:t>
+                      </a:r>
+                    </a:p>
+                  </a:txBody>
+                  <a:tcPr marL="6350" marR="6350" marT="6350" marB="0" anchor="b">
+                    <a:lnL w="6350" cap="flat" cmpd="sng" algn="ctr">
+                      <a:solidFill>
+                        <a:schemeClr val="tx1">
+                          <a:lumMod val="95000"/>
+                          <a:lumOff val="5000"/>
+                        </a:schemeClr>
+                      </a:solidFill>
+                      <a:prstDash val="solid"/>
+                      <a:round/>
+                      <a:headEnd type="none" w="med" len="med"/>
+                      <a:tailEnd type="none" w="med" len="med"/>
+                    </a:lnL>
+                    <a:lnR w="3175" cap="flat" cmpd="sng" algn="ctr">
+                      <a:solidFill>
+                        <a:schemeClr val="bg1">
+                          <a:lumMod val="65000"/>
+                        </a:schemeClr>
+                      </a:solidFill>
+                      <a:prstDash val="solid"/>
+                      <a:round/>
+                      <a:headEnd type="none" w="med" len="med"/>
+                      <a:tailEnd type="none" w="med" len="med"/>
+                    </a:lnR>
+                    <a:lnT w="3175" cap="flat" cmpd="sng" algn="ctr">
+                      <a:solidFill>
+                        <a:schemeClr val="bg1">
+                          <a:lumMod val="65000"/>
+                        </a:schemeClr>
+                      </a:solidFill>
+                      <a:prstDash val="solid"/>
+                      <a:round/>
+                      <a:headEnd type="none" w="med" len="med"/>
+                      <a:tailEnd type="none" w="med" len="med"/>
+                    </a:lnT>
+                    <a:lnB w="3175" cap="flat" cmpd="sng" algn="ctr">
+                      <a:solidFill>
+                        <a:schemeClr val="bg1">
+                          <a:lumMod val="65000"/>
+                        </a:schemeClr>
+                      </a:solidFill>
+                      <a:prstDash val="solid"/>
+                      <a:round/>
+                      <a:headEnd type="none" w="med" len="med"/>
+                      <a:tailEnd type="none" w="med" len="med"/>
+                    </a:lnB>
+                  </a:tcPr>
+                </a:tc>
+                <a:tc>
+                  <a:txBody>
+                    <a:bodyPr/>
+                    <a:lstStyle/>
+                    <a:p>
+                      <a:pPr algn="ctr" fontAlgn="b">
+                        <a:buNone/>
+                      </a:pPr>
+                      <a:r>
+                        <a:rPr lang="en-CA" sz="1200" b="0" i="0" u="none" strike="noStrike" dirty="0">
+                          <a:solidFill>
+                            <a:srgbClr val="000000"/>
+                          </a:solidFill>
+                          <a:effectLst/>
+                          <a:latin typeface="Courier New" panose="02070309020205020404" pitchFamily="49" charset="0"/>
+                          <a:cs typeface="Courier New" panose="02070309020205020404" pitchFamily="49" charset="0"/>
+                        </a:rPr>
+                        <a:t>vip50</a:t>
+                      </a:r>
+                    </a:p>
+                  </a:txBody>
+                  <a:tcPr marL="6350" marR="6350" marT="6350" marB="0" anchor="b">
+                    <a:lnL w="3175" cap="flat" cmpd="sng" algn="ctr">
+                      <a:solidFill>
+                        <a:schemeClr val="bg1">
+                          <a:lumMod val="65000"/>
+                        </a:schemeClr>
+                      </a:solidFill>
+                      <a:prstDash val="solid"/>
+                      <a:round/>
+                      <a:headEnd type="none" w="med" len="med"/>
+                      <a:tailEnd type="none" w="med" len="med"/>
+                    </a:lnL>
+                    <a:lnR w="3175" cap="flat" cmpd="sng" algn="ctr">
+                      <a:solidFill>
+                        <a:schemeClr val="bg1">
+                          <a:lumMod val="65000"/>
+                        </a:schemeClr>
+                      </a:solidFill>
+                      <a:prstDash val="solid"/>
+                      <a:round/>
+                      <a:headEnd type="none" w="med" len="med"/>
+                      <a:tailEnd type="none" w="med" len="med"/>
+                    </a:lnR>
+                    <a:lnT w="3175" cap="flat" cmpd="sng" algn="ctr">
+                      <a:solidFill>
+                        <a:schemeClr val="bg1">
+                          <a:lumMod val="65000"/>
+                        </a:schemeClr>
+                      </a:solidFill>
+                      <a:prstDash val="solid"/>
+                      <a:round/>
+                      <a:headEnd type="none" w="med" len="med"/>
+                      <a:tailEnd type="none" w="med" len="med"/>
+                    </a:lnT>
+                    <a:lnB w="3175" cap="flat" cmpd="sng" algn="ctr">
+                      <a:solidFill>
+                        <a:schemeClr val="bg1">
+                          <a:lumMod val="65000"/>
+                        </a:schemeClr>
+                      </a:solidFill>
+                      <a:prstDash val="solid"/>
+                      <a:round/>
+                      <a:headEnd type="none" w="med" len="med"/>
+                      <a:tailEnd type="none" w="med" len="med"/>
+                    </a:lnB>
+                  </a:tcPr>
+                </a:tc>
+                <a:tc>
+                  <a:txBody>
+                    <a:bodyPr/>
+                    <a:lstStyle/>
+                    <a:p>
+                      <a:pPr algn="ctr" fontAlgn="b">
+                        <a:buNone/>
+                      </a:pPr>
+                      <a:r>
+                        <a:rPr lang="en-CA" sz="1200" b="0" i="0" u="none" strike="noStrike" dirty="0">
+                          <a:solidFill>
+                            <a:srgbClr val="000000"/>
+                          </a:solidFill>
+                          <a:effectLst/>
+                          <a:latin typeface="Courier New" panose="02070309020205020404" pitchFamily="49" charset="0"/>
+                          <a:cs typeface="Courier New" panose="02070309020205020404" pitchFamily="49" charset="0"/>
+                        </a:rPr>
+                        <a:t>RSAD2</a:t>
+                      </a:r>
+                    </a:p>
+                  </a:txBody>
+                  <a:tcPr marL="6350" marR="6350" marT="6350" marB="0" anchor="b">
+                    <a:lnL w="3175" cap="flat" cmpd="sng" algn="ctr">
+                      <a:solidFill>
+                        <a:schemeClr val="bg1">
+                          <a:lumMod val="65000"/>
+                        </a:schemeClr>
+                      </a:solidFill>
+                      <a:prstDash val="solid"/>
+                      <a:round/>
+                      <a:headEnd type="none" w="med" len="med"/>
+                      <a:tailEnd type="none" w="med" len="med"/>
+                    </a:lnL>
+                    <a:lnR w="6350" cap="flat" cmpd="sng" algn="ctr">
+                      <a:solidFill>
+                        <a:schemeClr val="tx1">
+                          <a:lumMod val="95000"/>
+                          <a:lumOff val="5000"/>
+                        </a:schemeClr>
+                      </a:solidFill>
+                      <a:prstDash val="solid"/>
+                      <a:round/>
+                      <a:headEnd type="none" w="med" len="med"/>
+                      <a:tailEnd type="none" w="med" len="med"/>
+                    </a:lnR>
+                    <a:lnT w="3175" cap="flat" cmpd="sng" algn="ctr">
+                      <a:solidFill>
+                        <a:schemeClr val="bg1">
+                          <a:lumMod val="65000"/>
+                        </a:schemeClr>
+                      </a:solidFill>
+                      <a:prstDash val="solid"/>
+                      <a:round/>
+                      <a:headEnd type="none" w="med" len="med"/>
+                      <a:tailEnd type="none" w="med" len="med"/>
+                    </a:lnT>
+                    <a:lnB w="3175" cap="flat" cmpd="sng" algn="ctr">
+                      <a:solidFill>
+                        <a:schemeClr val="bg1">
+                          <a:lumMod val="65000"/>
+                        </a:schemeClr>
+                      </a:solidFill>
+                      <a:prstDash val="solid"/>
+                      <a:round/>
+                      <a:headEnd type="none" w="med" len="med"/>
+                      <a:tailEnd type="none" w="med" len="med"/>
+                    </a:lnB>
+                  </a:tcPr>
+                </a:tc>
+                <a:extLst>
+                  <a:ext uri="{0D108BD9-81ED-4DB2-BD59-A6C34878D82A}">
+                    <a16:rowId xmlns:a16="http://schemas.microsoft.com/office/drawing/2014/main" val="3353979791"/>
+                  </a:ext>
+                </a:extLst>
+              </a:tr>
+              <a:tr h="106163">
+                <a:tc>
+                  <a:txBody>
+                    <a:bodyPr/>
+                    <a:lstStyle/>
+                    <a:p>
+                      <a:pPr algn="ctr" fontAlgn="b">
+                        <a:buNone/>
+                      </a:pPr>
+                      <a:r>
+                        <a:rPr lang="en-CA" sz="1200" b="0" i="0" u="none" strike="noStrike" dirty="0">
+                          <a:solidFill>
+                            <a:srgbClr val="000000"/>
+                          </a:solidFill>
+                          <a:effectLst/>
+                          <a:latin typeface="Courier New" panose="02070309020205020404" pitchFamily="49" charset="0"/>
+                          <a:cs typeface="Courier New" panose="02070309020205020404" pitchFamily="49" charset="0"/>
+                        </a:rPr>
+                        <a:t>32937646</a:t>
+                      </a:r>
+                    </a:p>
+                  </a:txBody>
+                  <a:tcPr marL="6350" marR="6350" marT="6350" marB="0" anchor="b">
+                    <a:lnL w="6350" cap="flat" cmpd="sng" algn="ctr">
+                      <a:solidFill>
+                        <a:schemeClr val="tx1">
+                          <a:lumMod val="95000"/>
+                          <a:lumOff val="5000"/>
+                        </a:schemeClr>
+                      </a:solidFill>
+                      <a:prstDash val="solid"/>
+                      <a:round/>
+                      <a:headEnd type="none" w="med" len="med"/>
+                      <a:tailEnd type="none" w="med" len="med"/>
+                    </a:lnL>
+                    <a:lnR w="3175" cap="flat" cmpd="sng" algn="ctr">
+                      <a:solidFill>
+                        <a:schemeClr val="bg1">
+                          <a:lumMod val="65000"/>
+                        </a:schemeClr>
+                      </a:solidFill>
+                      <a:prstDash val="solid"/>
+                      <a:round/>
+                      <a:headEnd type="none" w="med" len="med"/>
+                      <a:tailEnd type="none" w="med" len="med"/>
+                    </a:lnR>
+                    <a:lnT w="3175" cap="flat" cmpd="sng" algn="ctr">
+                      <a:solidFill>
+                        <a:schemeClr val="bg1">
+                          <a:lumMod val="65000"/>
+                        </a:schemeClr>
+                      </a:solidFill>
+                      <a:prstDash val="solid"/>
+                      <a:round/>
+                      <a:headEnd type="none" w="med" len="med"/>
+                      <a:tailEnd type="none" w="med" len="med"/>
+                    </a:lnT>
+                    <a:lnB w="3175" cap="flat" cmpd="sng" algn="ctr">
+                      <a:solidFill>
+                        <a:schemeClr val="bg1">
+                          <a:lumMod val="65000"/>
+                        </a:schemeClr>
+                      </a:solidFill>
+                      <a:prstDash val="solid"/>
+                      <a:round/>
+                      <a:headEnd type="none" w="med" len="med"/>
+                      <a:tailEnd type="none" w="med" len="med"/>
+                    </a:lnB>
+                  </a:tcPr>
+                </a:tc>
+                <a:tc>
+                  <a:txBody>
+                    <a:bodyPr/>
+                    <a:lstStyle/>
+                    <a:p>
+                      <a:pPr algn="ctr" fontAlgn="b">
+                        <a:buNone/>
+                      </a:pPr>
+                      <a:r>
+                        <a:rPr lang="en-CA" sz="1200" b="0" i="0" u="none" strike="noStrike" dirty="0">
+                          <a:solidFill>
+                            <a:srgbClr val="000000"/>
+                          </a:solidFill>
+                          <a:effectLst/>
+                          <a:latin typeface="Courier New" panose="02070309020205020404" pitchFamily="49" charset="0"/>
+                          <a:cs typeface="Courier New" panose="02070309020205020404" pitchFamily="49" charset="0"/>
+                        </a:rPr>
+                        <a:t>vip56</a:t>
+                      </a:r>
+                    </a:p>
+                  </a:txBody>
+                  <a:tcPr marL="6350" marR="6350" marT="6350" marB="0" anchor="b">
+                    <a:lnL w="3175" cap="flat" cmpd="sng" algn="ctr">
+                      <a:solidFill>
+                        <a:schemeClr val="bg1">
+                          <a:lumMod val="65000"/>
+                        </a:schemeClr>
+                      </a:solidFill>
+                      <a:prstDash val="solid"/>
+                      <a:round/>
+                      <a:headEnd type="none" w="med" len="med"/>
+                      <a:tailEnd type="none" w="med" len="med"/>
+                    </a:lnL>
+                    <a:lnR w="3175" cap="flat" cmpd="sng" algn="ctr">
+                      <a:solidFill>
+                        <a:schemeClr val="bg1">
+                          <a:lumMod val="65000"/>
+                        </a:schemeClr>
+                      </a:solidFill>
+                      <a:prstDash val="solid"/>
+                      <a:round/>
+                      <a:headEnd type="none" w="med" len="med"/>
+                      <a:tailEnd type="none" w="med" len="med"/>
+                    </a:lnR>
+                    <a:lnT w="3175" cap="flat" cmpd="sng" algn="ctr">
+                      <a:solidFill>
+                        <a:schemeClr val="bg1">
+                          <a:lumMod val="65000"/>
+                        </a:schemeClr>
+                      </a:solidFill>
+                      <a:prstDash val="solid"/>
+                      <a:round/>
+                      <a:headEnd type="none" w="med" len="med"/>
+                      <a:tailEnd type="none" w="med" len="med"/>
+                    </a:lnT>
+                    <a:lnB w="3175" cap="flat" cmpd="sng" algn="ctr">
+                      <a:solidFill>
+                        <a:schemeClr val="bg1">
+                          <a:lumMod val="65000"/>
+                        </a:schemeClr>
+                      </a:solidFill>
+                      <a:prstDash val="solid"/>
+                      <a:round/>
+                      <a:headEnd type="none" w="med" len="med"/>
+                      <a:tailEnd type="none" w="med" len="med"/>
+                    </a:lnB>
+                  </a:tcPr>
+                </a:tc>
+                <a:tc>
+                  <a:txBody>
+                    <a:bodyPr/>
+                    <a:lstStyle/>
+                    <a:p>
+                      <a:pPr algn="ctr" fontAlgn="b">
+                        <a:buNone/>
+                      </a:pPr>
+                      <a:r>
+                        <a:rPr lang="en-CA" sz="1200" b="0" i="0" u="none" strike="noStrike" dirty="0">
+                          <a:solidFill>
+                            <a:srgbClr val="000000"/>
+                          </a:solidFill>
+                          <a:effectLst/>
+                          <a:latin typeface="Courier New" panose="02070309020205020404" pitchFamily="49" charset="0"/>
+                          <a:cs typeface="Courier New" panose="02070309020205020404" pitchFamily="49" charset="0"/>
+                        </a:rPr>
+                        <a:t>RSAD2</a:t>
+                      </a:r>
+                    </a:p>
+                  </a:txBody>
+                  <a:tcPr marL="6350" marR="6350" marT="6350" marB="0" anchor="b">
+                    <a:lnL w="3175" cap="flat" cmpd="sng" algn="ctr">
+                      <a:solidFill>
+                        <a:schemeClr val="bg1">
+                          <a:lumMod val="65000"/>
+                        </a:schemeClr>
+                      </a:solidFill>
+                      <a:prstDash val="solid"/>
+                      <a:round/>
+                      <a:headEnd type="none" w="med" len="med"/>
+                      <a:tailEnd type="none" w="med" len="med"/>
+                    </a:lnL>
+                    <a:lnR w="6350" cap="flat" cmpd="sng" algn="ctr">
+                      <a:solidFill>
+                        <a:schemeClr val="tx1">
+                          <a:lumMod val="95000"/>
+                          <a:lumOff val="5000"/>
+                        </a:schemeClr>
+                      </a:solidFill>
+                      <a:prstDash val="solid"/>
+                      <a:round/>
+                      <a:headEnd type="none" w="med" len="med"/>
+                      <a:tailEnd type="none" w="med" len="med"/>
+                    </a:lnR>
+                    <a:lnT w="3175" cap="flat" cmpd="sng" algn="ctr">
+                      <a:solidFill>
+                        <a:schemeClr val="bg1">
+                          <a:lumMod val="65000"/>
+                        </a:schemeClr>
+                      </a:solidFill>
+                      <a:prstDash val="solid"/>
+                      <a:round/>
+                      <a:headEnd type="none" w="med" len="med"/>
+                      <a:tailEnd type="none" w="med" len="med"/>
+                    </a:lnT>
+                    <a:lnB w="3175" cap="flat" cmpd="sng" algn="ctr">
+                      <a:solidFill>
+                        <a:schemeClr val="bg1">
+                          <a:lumMod val="65000"/>
+                        </a:schemeClr>
+                      </a:solidFill>
+                      <a:prstDash val="solid"/>
+                      <a:round/>
+                      <a:headEnd type="none" w="med" len="med"/>
+                      <a:tailEnd type="none" w="med" len="med"/>
+                    </a:lnB>
+                  </a:tcPr>
+                </a:tc>
+                <a:extLst>
+                  <a:ext uri="{0D108BD9-81ED-4DB2-BD59-A6C34878D82A}">
+                    <a16:rowId xmlns:a16="http://schemas.microsoft.com/office/drawing/2014/main" val="2567395982"/>
+                  </a:ext>
+                </a:extLst>
+              </a:tr>
+              <a:tr h="106163">
+                <a:tc>
+                  <a:txBody>
+                    <a:bodyPr/>
+                    <a:lstStyle/>
+                    <a:p>
+                      <a:pPr algn="ctr" fontAlgn="b">
+                        <a:buNone/>
+                      </a:pPr>
+                      <a:r>
+                        <a:rPr lang="en-CA" sz="1200" b="0" i="0" u="none" strike="noStrike" dirty="0">
+                          <a:solidFill>
+                            <a:srgbClr val="000000"/>
+                          </a:solidFill>
+                          <a:effectLst/>
+                          <a:latin typeface="Courier New" panose="02070309020205020404" pitchFamily="49" charset="0"/>
+                          <a:cs typeface="Courier New" panose="02070309020205020404" pitchFamily="49" charset="0"/>
+                        </a:rPr>
+                        <a:t>32937646</a:t>
+                      </a:r>
+                    </a:p>
+                  </a:txBody>
+                  <a:tcPr marL="6350" marR="6350" marT="6350" marB="0" anchor="b">
+                    <a:lnL w="6350" cap="flat" cmpd="sng" algn="ctr">
+                      <a:solidFill>
+                        <a:schemeClr val="tx1">
+                          <a:lumMod val="95000"/>
+                          <a:lumOff val="5000"/>
+                        </a:schemeClr>
+                      </a:solidFill>
+                      <a:prstDash val="solid"/>
+                      <a:round/>
+                      <a:headEnd type="none" w="med" len="med"/>
+                      <a:tailEnd type="none" w="med" len="med"/>
+                    </a:lnL>
+                    <a:lnR w="3175" cap="flat" cmpd="sng" algn="ctr">
+                      <a:solidFill>
+                        <a:schemeClr val="bg1">
+                          <a:lumMod val="65000"/>
+                        </a:schemeClr>
+                      </a:solidFill>
+                      <a:prstDash val="solid"/>
+                      <a:round/>
+                      <a:headEnd type="none" w="med" len="med"/>
+                      <a:tailEnd type="none" w="med" len="med"/>
+                    </a:lnR>
+                    <a:lnT w="3175" cap="flat" cmpd="sng" algn="ctr">
+                      <a:solidFill>
+                        <a:schemeClr val="bg1">
+                          <a:lumMod val="65000"/>
+                        </a:schemeClr>
+                      </a:solidFill>
+                      <a:prstDash val="solid"/>
+                      <a:round/>
+                      <a:headEnd type="none" w="med" len="med"/>
+                      <a:tailEnd type="none" w="med" len="med"/>
+                    </a:lnT>
+                    <a:lnB w="3175" cap="flat" cmpd="sng" algn="ctr">
+                      <a:solidFill>
+                        <a:schemeClr val="bg1">
+                          <a:lumMod val="65000"/>
+                        </a:schemeClr>
+                      </a:solidFill>
+                      <a:prstDash val="solid"/>
+                      <a:round/>
+                      <a:headEnd type="none" w="med" len="med"/>
+                      <a:tailEnd type="none" w="med" len="med"/>
+                    </a:lnB>
+                  </a:tcPr>
+                </a:tc>
+                <a:tc>
+                  <a:txBody>
+                    <a:bodyPr/>
+                    <a:lstStyle/>
+                    <a:p>
+                      <a:pPr algn="ctr" fontAlgn="b">
+                        <a:buNone/>
+                      </a:pPr>
+                      <a:r>
+                        <a:rPr lang="en-CA" sz="1200" b="0" i="0" u="none" strike="noStrike" dirty="0">
+                          <a:solidFill>
+                            <a:srgbClr val="000000"/>
+                          </a:solidFill>
+                          <a:effectLst/>
+                          <a:latin typeface="Courier New" panose="02070309020205020404" pitchFamily="49" charset="0"/>
+                          <a:cs typeface="Courier New" panose="02070309020205020404" pitchFamily="49" charset="0"/>
+                        </a:rPr>
+                        <a:t>vip58</a:t>
+                      </a:r>
+                    </a:p>
+                  </a:txBody>
+                  <a:tcPr marL="6350" marR="6350" marT="6350" marB="0" anchor="b">
+                    <a:lnL w="3175" cap="flat" cmpd="sng" algn="ctr">
+                      <a:solidFill>
+                        <a:schemeClr val="bg1">
+                          <a:lumMod val="65000"/>
+                        </a:schemeClr>
+                      </a:solidFill>
+                      <a:prstDash val="solid"/>
+                      <a:round/>
+                      <a:headEnd type="none" w="med" len="med"/>
+                      <a:tailEnd type="none" w="med" len="med"/>
+                    </a:lnL>
+                    <a:lnR w="3175" cap="flat" cmpd="sng" algn="ctr">
+                      <a:solidFill>
+                        <a:schemeClr val="bg1">
+                          <a:lumMod val="65000"/>
+                        </a:schemeClr>
+                      </a:solidFill>
+                      <a:prstDash val="solid"/>
+                      <a:round/>
+                      <a:headEnd type="none" w="med" len="med"/>
+                      <a:tailEnd type="none" w="med" len="med"/>
+                    </a:lnR>
+                    <a:lnT w="3175" cap="flat" cmpd="sng" algn="ctr">
+                      <a:solidFill>
+                        <a:schemeClr val="bg1">
+                          <a:lumMod val="65000"/>
+                        </a:schemeClr>
+                      </a:solidFill>
+                      <a:prstDash val="solid"/>
+                      <a:round/>
+                      <a:headEnd type="none" w="med" len="med"/>
+                      <a:tailEnd type="none" w="med" len="med"/>
+                    </a:lnT>
+                    <a:lnB w="3175" cap="flat" cmpd="sng" algn="ctr">
+                      <a:solidFill>
+                        <a:schemeClr val="bg1">
+                          <a:lumMod val="65000"/>
+                        </a:schemeClr>
+                      </a:solidFill>
+                      <a:prstDash val="solid"/>
+                      <a:round/>
+                      <a:headEnd type="none" w="med" len="med"/>
+                      <a:tailEnd type="none" w="med" len="med"/>
+                    </a:lnB>
+                  </a:tcPr>
+                </a:tc>
+                <a:tc>
+                  <a:txBody>
+                    <a:bodyPr/>
+                    <a:lstStyle/>
+                    <a:p>
+                      <a:pPr algn="ctr" fontAlgn="b">
+                        <a:buNone/>
+                      </a:pPr>
+                      <a:r>
+                        <a:rPr lang="en-CA" sz="1200" b="0" i="0" u="none" strike="noStrike" dirty="0">
+                          <a:solidFill>
+                            <a:srgbClr val="000000"/>
+                          </a:solidFill>
+                          <a:effectLst/>
+                          <a:latin typeface="Courier New" panose="02070309020205020404" pitchFamily="49" charset="0"/>
+                          <a:cs typeface="Courier New" panose="02070309020205020404" pitchFamily="49" charset="0"/>
+                        </a:rPr>
+                        <a:t>RSAD2</a:t>
+                      </a:r>
+                    </a:p>
+                  </a:txBody>
+                  <a:tcPr marL="6350" marR="6350" marT="6350" marB="0" anchor="b">
+                    <a:lnL w="3175" cap="flat" cmpd="sng" algn="ctr">
+                      <a:solidFill>
+                        <a:schemeClr val="bg1">
+                          <a:lumMod val="65000"/>
+                        </a:schemeClr>
+                      </a:solidFill>
+                      <a:prstDash val="solid"/>
+                      <a:round/>
+                      <a:headEnd type="none" w="med" len="med"/>
+                      <a:tailEnd type="none" w="med" len="med"/>
+                    </a:lnL>
+                    <a:lnR w="6350" cap="flat" cmpd="sng" algn="ctr">
+                      <a:solidFill>
+                        <a:schemeClr val="tx1">
+                          <a:lumMod val="95000"/>
+                          <a:lumOff val="5000"/>
+                        </a:schemeClr>
+                      </a:solidFill>
+                      <a:prstDash val="solid"/>
+                      <a:round/>
+                      <a:headEnd type="none" w="med" len="med"/>
+                      <a:tailEnd type="none" w="med" len="med"/>
+                    </a:lnR>
+                    <a:lnT w="3175" cap="flat" cmpd="sng" algn="ctr">
+                      <a:solidFill>
+                        <a:schemeClr val="bg1">
+                          <a:lumMod val="65000"/>
+                        </a:schemeClr>
+                      </a:solidFill>
+                      <a:prstDash val="solid"/>
+                      <a:round/>
+                      <a:headEnd type="none" w="med" len="med"/>
+                      <a:tailEnd type="none" w="med" len="med"/>
+                    </a:lnT>
+                    <a:lnB w="3175" cap="flat" cmpd="sng" algn="ctr">
+                      <a:solidFill>
+                        <a:schemeClr val="bg1">
+                          <a:lumMod val="65000"/>
+                        </a:schemeClr>
+                      </a:solidFill>
+                      <a:prstDash val="solid"/>
+                      <a:round/>
+                      <a:headEnd type="none" w="med" len="med"/>
+                      <a:tailEnd type="none" w="med" len="med"/>
+                    </a:lnB>
+                  </a:tcPr>
+                </a:tc>
+                <a:extLst>
+                  <a:ext uri="{0D108BD9-81ED-4DB2-BD59-A6C34878D82A}">
+                    <a16:rowId xmlns:a16="http://schemas.microsoft.com/office/drawing/2014/main" val="839730952"/>
+                  </a:ext>
+                </a:extLst>
+              </a:tr>
+              <a:tr h="106163">
+                <a:tc>
+                  <a:txBody>
+                    <a:bodyPr/>
+                    <a:lstStyle/>
+                    <a:p>
+                      <a:pPr algn="ctr" fontAlgn="b">
+                        <a:buNone/>
+                      </a:pPr>
+                      <a:r>
+                        <a:rPr lang="en-CA" sz="1200" b="0" i="0" u="none" strike="noStrike" dirty="0">
+                          <a:solidFill>
+                            <a:srgbClr val="000000"/>
+                          </a:solidFill>
+                          <a:effectLst/>
+                          <a:latin typeface="Courier New" panose="02070309020205020404" pitchFamily="49" charset="0"/>
+                          <a:cs typeface="Courier New" panose="02070309020205020404" pitchFamily="49" charset="0"/>
+                        </a:rPr>
+                        <a:t>32937646</a:t>
+                      </a:r>
+                    </a:p>
+                  </a:txBody>
+                  <a:tcPr marL="6350" marR="6350" marT="6350" marB="0" anchor="b">
+                    <a:lnL w="6350" cap="flat" cmpd="sng" algn="ctr">
+                      <a:solidFill>
+                        <a:schemeClr val="tx1">
+                          <a:lumMod val="95000"/>
+                          <a:lumOff val="5000"/>
+                        </a:schemeClr>
+                      </a:solidFill>
+                      <a:prstDash val="solid"/>
+                      <a:round/>
+                      <a:headEnd type="none" w="med" len="med"/>
+                      <a:tailEnd type="none" w="med" len="med"/>
+                    </a:lnL>
+                    <a:lnR w="3175" cap="flat" cmpd="sng" algn="ctr">
+                      <a:solidFill>
+                        <a:schemeClr val="bg1">
+                          <a:lumMod val="65000"/>
+                        </a:schemeClr>
+                      </a:solidFill>
+                      <a:prstDash val="solid"/>
+                      <a:round/>
+                      <a:headEnd type="none" w="med" len="med"/>
+                      <a:tailEnd type="none" w="med" len="med"/>
+                    </a:lnR>
+                    <a:lnT w="3175" cap="flat" cmpd="sng" algn="ctr">
+                      <a:solidFill>
+                        <a:schemeClr val="bg1">
+                          <a:lumMod val="65000"/>
+                        </a:schemeClr>
+                      </a:solidFill>
+                      <a:prstDash val="solid"/>
+                      <a:round/>
+                      <a:headEnd type="none" w="med" len="med"/>
+                      <a:tailEnd type="none" w="med" len="med"/>
+                    </a:lnT>
+                    <a:lnB w="6350" cap="flat" cmpd="sng" algn="ctr">
+                      <a:solidFill>
+                        <a:schemeClr val="tx1">
+                          <a:lumMod val="95000"/>
+                          <a:lumOff val="5000"/>
+                        </a:schemeClr>
+                      </a:solidFill>
+                      <a:prstDash val="solid"/>
+                      <a:round/>
+                      <a:headEnd type="none" w="med" len="med"/>
+                      <a:tailEnd type="none" w="med" len="med"/>
+                    </a:lnB>
+                  </a:tcPr>
+                </a:tc>
+                <a:tc>
+                  <a:txBody>
+                    <a:bodyPr/>
+                    <a:lstStyle/>
+                    <a:p>
+                      <a:pPr algn="ctr" fontAlgn="b">
+                        <a:buNone/>
+                      </a:pPr>
+                      <a:r>
+                        <a:rPr lang="en-CA" sz="1200" b="0" i="0" u="none" strike="noStrike" dirty="0">
+                          <a:solidFill>
+                            <a:srgbClr val="000000"/>
+                          </a:solidFill>
+                          <a:effectLst/>
+                          <a:latin typeface="Courier New" panose="02070309020205020404" pitchFamily="49" charset="0"/>
+                          <a:cs typeface="Courier New" panose="02070309020205020404" pitchFamily="49" charset="0"/>
+                        </a:rPr>
+                        <a:t>vip60</a:t>
+                      </a:r>
+                    </a:p>
+                  </a:txBody>
+                  <a:tcPr marL="6350" marR="6350" marT="6350" marB="0" anchor="b">
+                    <a:lnL w="3175" cap="flat" cmpd="sng" algn="ctr">
+                      <a:solidFill>
+                        <a:schemeClr val="bg1">
+                          <a:lumMod val="65000"/>
+                        </a:schemeClr>
+                      </a:solidFill>
+                      <a:prstDash val="solid"/>
+                      <a:round/>
+                      <a:headEnd type="none" w="med" len="med"/>
+                      <a:tailEnd type="none" w="med" len="med"/>
+                    </a:lnL>
+                    <a:lnR w="3175" cap="flat" cmpd="sng" algn="ctr">
+                      <a:solidFill>
+                        <a:schemeClr val="bg1">
+                          <a:lumMod val="65000"/>
+                        </a:schemeClr>
+                      </a:solidFill>
+                      <a:prstDash val="solid"/>
+                      <a:round/>
+                      <a:headEnd type="none" w="med" len="med"/>
+                      <a:tailEnd type="none" w="med" len="med"/>
+                    </a:lnR>
+                    <a:lnT w="3175" cap="flat" cmpd="sng" algn="ctr">
+                      <a:solidFill>
+                        <a:schemeClr val="bg1">
+                          <a:lumMod val="65000"/>
+                        </a:schemeClr>
+                      </a:solidFill>
+                      <a:prstDash val="solid"/>
+                      <a:round/>
+                      <a:headEnd type="none" w="med" len="med"/>
+                      <a:tailEnd type="none" w="med" len="med"/>
+                    </a:lnT>
+                    <a:lnB w="6350" cap="flat" cmpd="sng" algn="ctr">
+                      <a:solidFill>
+                        <a:schemeClr val="tx1">
+                          <a:lumMod val="95000"/>
+                          <a:lumOff val="5000"/>
+                        </a:schemeClr>
+                      </a:solidFill>
+                      <a:prstDash val="solid"/>
+                      <a:round/>
+                      <a:headEnd type="none" w="med" len="med"/>
+                      <a:tailEnd type="none" w="med" len="med"/>
+                    </a:lnB>
+                  </a:tcPr>
+                </a:tc>
+                <a:tc>
+                  <a:txBody>
+                    <a:bodyPr/>
+                    <a:lstStyle/>
+                    <a:p>
+                      <a:pPr algn="ctr" fontAlgn="b">
+                        <a:buNone/>
+                      </a:pPr>
+                      <a:r>
+                        <a:rPr lang="en-CA" sz="1200" b="0" i="0" u="none" strike="noStrike" dirty="0">
+                          <a:solidFill>
+                            <a:srgbClr val="000000"/>
+                          </a:solidFill>
+                          <a:effectLst/>
+                          <a:latin typeface="Courier New" panose="02070309020205020404" pitchFamily="49" charset="0"/>
+                          <a:cs typeface="Courier New" panose="02070309020205020404" pitchFamily="49" charset="0"/>
+                        </a:rPr>
+                        <a:t>RSAD2</a:t>
+                      </a:r>
+                    </a:p>
+                  </a:txBody>
+                  <a:tcPr marL="6350" marR="6350" marT="6350" marB="0" anchor="b">
+                    <a:lnL w="3175" cap="flat" cmpd="sng" algn="ctr">
+                      <a:solidFill>
+                        <a:schemeClr val="bg1">
+                          <a:lumMod val="65000"/>
+                        </a:schemeClr>
+                      </a:solidFill>
+                      <a:prstDash val="solid"/>
+                      <a:round/>
+                      <a:headEnd type="none" w="med" len="med"/>
+                      <a:tailEnd type="none" w="med" len="med"/>
+                    </a:lnL>
+                    <a:lnR w="6350" cap="flat" cmpd="sng" algn="ctr">
+                      <a:solidFill>
+                        <a:schemeClr val="tx1">
+                          <a:lumMod val="95000"/>
+                          <a:lumOff val="5000"/>
+                        </a:schemeClr>
+                      </a:solidFill>
+                      <a:prstDash val="solid"/>
+                      <a:round/>
+                      <a:headEnd type="none" w="med" len="med"/>
+                      <a:tailEnd type="none" w="med" len="med"/>
+                    </a:lnR>
+                    <a:lnT w="3175" cap="flat" cmpd="sng" algn="ctr">
+                      <a:solidFill>
+                        <a:schemeClr val="bg1">
+                          <a:lumMod val="65000"/>
+                        </a:schemeClr>
+                      </a:solidFill>
+                      <a:prstDash val="solid"/>
+                      <a:round/>
+                      <a:headEnd type="none" w="med" len="med"/>
+                      <a:tailEnd type="none" w="med" len="med"/>
+                    </a:lnT>
+                    <a:lnB w="6350" cap="flat" cmpd="sng" algn="ctr">
+                      <a:solidFill>
+                        <a:schemeClr val="tx1">
+                          <a:lumMod val="95000"/>
+                          <a:lumOff val="5000"/>
+                        </a:schemeClr>
+                      </a:solidFill>
+                      <a:prstDash val="solid"/>
+                      <a:round/>
+                      <a:headEnd type="none" w="med" len="med"/>
+                      <a:tailEnd type="none" w="med" len="med"/>
+                    </a:lnB>
+                  </a:tcPr>
+                </a:tc>
+                <a:extLst>
+                  <a:ext uri="{0D108BD9-81ED-4DB2-BD59-A6C34878D82A}">
+                    <a16:rowId xmlns:a16="http://schemas.microsoft.com/office/drawing/2014/main" val="2423425260"/>
+                  </a:ext>
+                </a:extLst>
+              </a:tr>
+            </a:tbl>
+          </a:graphicData>
+        </a:graphic>
+      </p:graphicFrame>
+      <p:sp>
+        <p:nvSpPr>
+          <p:cNvPr id="3" name="TextBox 2">
+            <a:extLst>
+              <a:ext uri="{FF2B5EF4-FFF2-40B4-BE49-F238E27FC236}">
+                <a16:creationId xmlns:a16="http://schemas.microsoft.com/office/drawing/2014/main" id="{8DA5EAAB-16B0-2623-CF1A-2B61D1BF787A}"/>
+              </a:ext>
+            </a:extLst>
+          </p:cNvPr>
+          <p:cNvSpPr txBox="1"/>
+          <p:nvPr/>
+        </p:nvSpPr>
+        <p:spPr>
+          <a:xfrm>
+            <a:off x="1241192" y="1004062"/>
+            <a:ext cx="4489704" cy="1384995"/>
+          </a:xfrm>
+          <a:prstGeom prst="rect">
+            <a:avLst/>
+          </a:prstGeom>
+          <a:noFill/>
+          <a:ln>
+            <a:solidFill>
+              <a:schemeClr val="tx1">
+                <a:lumMod val="65000"/>
+                <a:lumOff val="35000"/>
+              </a:schemeClr>
+            </a:solidFill>
+          </a:ln>
+        </p:spPr>
+        <p:txBody>
+          <a:bodyPr wrap="square" rtlCol="0">
+            <a:spAutoFit/>
+          </a:bodyPr>
+          <a:lstStyle/>
+          <a:p>
+            <a:r>
+              <a:rPr lang="en-US" sz="1200" dirty="0">
+                <a:latin typeface="Lucida Console" panose="020B0609040504020204" pitchFamily="49" charset="0"/>
+              </a:rPr>
+              <a:t>Source: high-impact literature</a:t>
+            </a:r>
+          </a:p>
+          <a:p>
+            <a:endParaRPr lang="en-US" sz="1200" dirty="0">
+              <a:latin typeface="Lucida Console" panose="020B0609040504020204" pitchFamily="49" charset="0"/>
+            </a:endParaRPr>
+          </a:p>
+          <a:p>
+            <a:r>
+              <a:rPr lang="en-US" sz="1200" dirty="0">
+                <a:latin typeface="Lucida Console" panose="020B0609040504020204" pitchFamily="49" charset="0"/>
+              </a:rPr>
+              <a:t>Criteria: bacterial homology to human, proof of bacterial immune function</a:t>
+            </a:r>
+          </a:p>
+          <a:p>
+            <a:endParaRPr lang="en-US" sz="1200" dirty="0">
+              <a:latin typeface="Lucida Console" panose="020B0609040504020204" pitchFamily="49" charset="0"/>
+            </a:endParaRPr>
+          </a:p>
+          <a:p>
+            <a:r>
+              <a:rPr lang="en-US" sz="1200" dirty="0">
+                <a:latin typeface="Lucida Console" panose="020B0609040504020204" pitchFamily="49" charset="0"/>
+              </a:rPr>
+              <a:t>Purpose: positive control for subsequence analysis</a:t>
+            </a:r>
+            <a:endParaRPr lang="en-CA" sz="1200" dirty="0">
+              <a:latin typeface="Lucida Console" panose="020B0609040504020204" pitchFamily="49" charset="0"/>
+            </a:endParaRPr>
+          </a:p>
+        </p:txBody>
+      </p:sp>
+      <p:cxnSp>
+        <p:nvCxnSpPr>
+          <p:cNvPr id="7" name="Straight Arrow Connector 6">
+            <a:extLst>
+              <a:ext uri="{FF2B5EF4-FFF2-40B4-BE49-F238E27FC236}">
+                <a16:creationId xmlns:a16="http://schemas.microsoft.com/office/drawing/2014/main" id="{1D7F113A-51DC-5CB6-7C05-0C559A2EC737}"/>
+              </a:ext>
+            </a:extLst>
+          </p:cNvPr>
+          <p:cNvCxnSpPr>
+            <a:cxnSpLocks/>
+          </p:cNvCxnSpPr>
+          <p:nvPr/>
+        </p:nvCxnSpPr>
+        <p:spPr>
+          <a:xfrm>
+            <a:off x="6318504" y="1696559"/>
+            <a:ext cx="0" cy="922308"/>
+          </a:xfrm>
+          <a:prstGeom prst="straightConnector1">
+            <a:avLst/>
+          </a:prstGeom>
+          <a:ln>
+            <a:solidFill>
+              <a:schemeClr val="tx1"/>
+            </a:solidFill>
+            <a:tailEnd type="triangle"/>
+          </a:ln>
+        </p:spPr>
+        <p:style>
+          <a:lnRef idx="2">
+            <a:schemeClr val="accent1"/>
+          </a:lnRef>
+          <a:fillRef idx="0">
+            <a:schemeClr val="accent1"/>
+          </a:fillRef>
+          <a:effectRef idx="1">
+            <a:schemeClr val="accent1"/>
+          </a:effectRef>
+          <a:fontRef idx="minor">
+            <a:schemeClr val="tx1"/>
+          </a:fontRef>
+        </p:style>
+      </p:cxnSp>
+      <p:cxnSp>
+        <p:nvCxnSpPr>
+          <p:cNvPr id="11" name="Straight Connector 10">
+            <a:extLst>
+              <a:ext uri="{FF2B5EF4-FFF2-40B4-BE49-F238E27FC236}">
+                <a16:creationId xmlns:a16="http://schemas.microsoft.com/office/drawing/2014/main" id="{DB24020F-D695-FDE0-F782-285CFA8CE4CF}"/>
+              </a:ext>
+            </a:extLst>
+          </p:cNvPr>
+          <p:cNvCxnSpPr>
+            <a:cxnSpLocks/>
+            <a:stCxn id="3" idx="3"/>
+          </p:cNvCxnSpPr>
+          <p:nvPr/>
+        </p:nvCxnSpPr>
+        <p:spPr>
+          <a:xfrm>
+            <a:off x="5730896" y="1696560"/>
+            <a:ext cx="587608" cy="0"/>
+          </a:xfrm>
+          <a:prstGeom prst="line">
+            <a:avLst/>
+          </a:prstGeom>
+        </p:spPr>
+        <p:style>
+          <a:lnRef idx="2">
+            <a:schemeClr val="accent1"/>
+          </a:lnRef>
+          <a:fillRef idx="0">
+            <a:schemeClr val="accent1"/>
+          </a:fillRef>
+          <a:effectRef idx="1">
+            <a:schemeClr val="accent1"/>
+          </a:effectRef>
+          <a:fontRef idx="minor">
+            <a:schemeClr val="tx1"/>
+          </a:fontRef>
+        </p:style>
+      </p:cxnSp>
+      <p:sp>
+        <p:nvSpPr>
+          <p:cNvPr id="13" name="TextBox 12">
+            <a:extLst>
+              <a:ext uri="{FF2B5EF4-FFF2-40B4-BE49-F238E27FC236}">
+                <a16:creationId xmlns:a16="http://schemas.microsoft.com/office/drawing/2014/main" id="{CA6E3BA6-4697-4E8A-416B-A332B9C216CB}"/>
+              </a:ext>
+            </a:extLst>
+          </p:cNvPr>
+          <p:cNvSpPr txBox="1"/>
+          <p:nvPr/>
+        </p:nvSpPr>
+        <p:spPr>
+          <a:xfrm>
+            <a:off x="1232048" y="6222191"/>
+            <a:ext cx="2670048" cy="276999"/>
+          </a:xfrm>
+          <a:prstGeom prst="rect">
+            <a:avLst/>
+          </a:prstGeom>
+          <a:noFill/>
+          <a:ln>
+            <a:solidFill>
+              <a:schemeClr val="tx1"/>
+            </a:solidFill>
+          </a:ln>
+        </p:spPr>
+        <p:txBody>
+          <a:bodyPr wrap="square" rtlCol="0">
+            <a:spAutoFit/>
+          </a:bodyPr>
+          <a:lstStyle/>
+          <a:p>
+            <a:r>
+              <a:rPr lang="en-US" sz="1200" dirty="0">
+                <a:latin typeface="Lucida Console" panose="020B0609040504020204" pitchFamily="49" charset="0"/>
+              </a:rPr>
+              <a:t>Total number: 18 pairs</a:t>
+            </a:r>
+            <a:endParaRPr lang="en-CA" sz="1200" dirty="0">
+              <a:latin typeface="Lucida Console" panose="020B0609040504020204" pitchFamily="49" charset="0"/>
             </a:endParaRPr>
           </a:p>
         </p:txBody>

</xml_diff>